<commit_message>
Agregar cronograma Gantt del Dojo AM al deck
Slide con fechas por fase y tarea, del 14/09/2026 al 02/04/2027, con
hitos y receso de fin de año.

Co-Authored-By: Claude Fable 5.1 <noreply@anthropic.com>
Claude-Session: https://claude.ai/code/session_013R5zM6jAzpk9971GWdT5eG
</commit_message>
<xml_diff>
--- a/docs/Dojo_AM_Unidad_Pintura.pptx
+++ b/docs/Dojo_AM_Unidad_Pintura.pptx
@@ -19,9 +19,10 @@
     <p:sldId id="267" r:id="rId13"/>
     <p:sldId id="268" r:id="rId14"/>
     <p:sldId id="269" r:id="rId15"/>
+    <p:sldId id="270" r:id="rId16"/>
   </p:sldIdLst>
   <p:notesMasterIdLst>
-    <p:notesMasterId r:id="rId16"/>
+    <p:notesMasterId r:id="rId17"/>
   </p:notesMasterIdLst>
   <p:sldSz cx="12192000" cy="6858000"/>
   <p:notesSz cx="6858000" cy="12192000"/>
@@ -867,7 +868,7 @@
           <a:p>
             <a:r>
               <a:rPr lang="en-US" dirty="0"/>
-              <a:t>Indicadores propuestos: operarios certificados, participación en los juegos, anomalías detectadas por operarios, intervenciones básicas resueltas por Producción y paradas por causas básicas.</a:t>
+              <a:t>Cronograma propuesto de 29 semanas: diseño en septiembre, construcción de octubre a noviembre, piloto en diciembre y despliegue de enero a abril de 2027. Los hitos marcan las decisiones clave: aprobación del layout y presupuesto, maquetas listas, go/no-go y cierre del despliegue.</a:t>
             </a:r>
             <a:endParaRPr lang="en-US" dirty="0"/>
           </a:p>
@@ -955,7 +956,7 @@
           <a:p>
             <a:r>
               <a:rPr lang="en-US" dirty="0"/>
-              <a:t>Cierre: el Dojo es un espacio para aprender, practicar y crecer juntos. El próximo paso es aprobar el espacio y arrancar la fase de diseño.</a:t>
+              <a:t>Indicadores propuestos: operarios certificados, participación en los juegos, anomalías detectadas por operarios, intervenciones básicas resueltas por Producción y paradas por causas básicas.</a:t>
             </a:r>
             <a:endParaRPr lang="en-US" dirty="0"/>
           </a:p>
@@ -979,6 +980,94 @@
             <a:fld id="{F7021451-1387-4CA6-816F-3879F97B5CBC}" type="slidenum">
               <a:rPr lang="en-US"/>
               <a:t>14</a:t>
+            </a:fld>
+            <a:endParaRPr lang="en-US"/>
+          </a:p>
+        </p:txBody>
+      </p:sp>
+    </p:spTree>
+    <p:extLst>
+      <p:ext uri="{BB962C8B-B14F-4D97-AF65-F5344CB8AC3E}">
+        <p14:creationId xmlns:p14="http://schemas.microsoft.com/office/powerpoint/2010/main" val="1024086991"/>
+      </p:ext>
+    </p:extLst>
+  </p:cSld>
+  <p:clrMapOvr>
+    <a:masterClrMapping/>
+  </p:clrMapOvr>
+</p:notes>
+</file>
+
+<file path=ppt/notesSlides/notesSlide15.xml><?xml version="1.0" encoding="utf-8"?>
+<p:notes xmlns:a="http://schemas.openxmlformats.org/drawingml/2006/main" xmlns:r="http://schemas.openxmlformats.org/officeDocument/2006/relationships" xmlns:p="http://schemas.openxmlformats.org/presentationml/2006/main">
+  <p:cSld>
+    <p:spTree>
+      <p:nvGrpSpPr>
+        <p:cNvPr id="1" name=""/>
+        <p:cNvGrpSpPr/>
+        <p:nvPr/>
+      </p:nvGrpSpPr>
+      <p:grpSpPr>
+        <a:xfrm>
+          <a:off x="0" y="0"/>
+          <a:ext cx="0" cy="0"/>
+          <a:chOff x="0" y="0"/>
+          <a:chExt cx="0" cy="0"/>
+        </a:xfrm>
+      </p:grpSpPr>
+      <p:sp>
+        <p:nvSpPr>
+          <p:cNvPr id="2" name="Slide Image Placeholder 1"/>
+          <p:cNvSpPr>
+            <a:spLocks noGrp="1" noRot="1" noChangeAspect="1"/>
+          </p:cNvSpPr>
+          <p:nvPr>
+            <p:ph type="sldImg"/>
+          </p:nvPr>
+        </p:nvSpPr>
+        <p:spPr/>
+      </p:sp>
+      <p:sp>
+        <p:nvSpPr>
+          <p:cNvPr id="3" name="Notes Placeholder 2"/>
+          <p:cNvSpPr>
+            <a:spLocks noGrp="1"/>
+          </p:cNvSpPr>
+          <p:nvPr>
+            <p:ph type="body" idx="1"/>
+          </p:nvPr>
+        </p:nvSpPr>
+        <p:spPr/>
+        <p:txBody>
+          <a:bodyPr/>
+          <a:lstStyle/>
+          <a:p>
+            <a:r>
+              <a:rPr lang="en-US" dirty="0"/>
+              <a:t>Cierre: el Dojo es un espacio para aprender, practicar y crecer juntos. El próximo paso es aprobar el espacio y arrancar la fase de diseño.</a:t>
+            </a:r>
+            <a:endParaRPr lang="en-US" dirty="0"/>
+          </a:p>
+        </p:txBody>
+      </p:sp>
+      <p:sp>
+        <p:nvSpPr>
+          <p:cNvPr id="4" name="Slide Number Placeholder 3"/>
+          <p:cNvSpPr>
+            <a:spLocks noGrp="1"/>
+          </p:cNvSpPr>
+          <p:nvPr>
+            <p:ph type="sldNum" sz="quarter" idx="10"/>
+          </p:nvPr>
+        </p:nvSpPr>
+        <p:spPr/>
+        <p:txBody>
+          <a:bodyPr/>
+          <a:lstStyle/>
+          <a:p>
+            <a:fld id="{F7021451-1387-4CA6-816F-3879F97B5CBC}" type="slidenum">
+              <a:rPr lang="en-US"/>
+              <a:t>15</a:t>
             </a:fld>
             <a:endParaRPr lang="en-US"/>
           </a:p>
@@ -5439,6 +5528,3060 @@
     <p:bg>
       <p:bgPr>
         <a:solidFill>
+          <a:srgbClr val="FFFFFF"/>
+        </a:solidFill>
+      </p:bgPr>
+    </p:bg>
+    <p:spTree>
+      <p:nvGrpSpPr>
+        <p:cNvPr id="1" name=""/>
+        <p:cNvGrpSpPr/>
+        <p:nvPr/>
+      </p:nvGrpSpPr>
+      <p:grpSpPr>
+        <a:xfrm>
+          <a:off x="0" y="0"/>
+          <a:ext cx="0" cy="0"/>
+          <a:chOff x="0" y="0"/>
+          <a:chExt cx="0" cy="0"/>
+        </a:xfrm>
+      </p:grpSpPr>
+      <p:sp>
+        <p:nvSpPr>
+          <p:cNvPr id="2" name="Text 0"/>
+          <p:cNvSpPr txBox="1"/>
+          <p:nvPr/>
+        </p:nvSpPr>
+        <p:spPr>
+          <a:xfrm>
+            <a:off x="548640" y="365760"/>
+            <a:ext cx="8595360" cy="777240"/>
+          </a:xfrm>
+          <a:prstGeom prst="rect">
+            <a:avLst/>
+          </a:prstGeom>
+          <a:noFill/>
+          <a:ln/>
+        </p:spPr>
+        <p:txBody>
+          <a:bodyPr wrap="square" lIns="0" tIns="0" rIns="0" bIns="0" rtlCol="0" anchor="ctr"/>
+          <a:lstStyle/>
+          <a:p>
+            <a:pPr indent="0" marL="0">
+              <a:buNone/>
+            </a:pPr>
+            <a:r>
+              <a:rPr lang="en-US" sz="2800" b="1" dirty="0">
+                <a:solidFill>
+                  <a:srgbClr val="022A5B"/>
+                </a:solidFill>
+                <a:latin typeface="Arial" pitchFamily="34" charset="0"/>
+                <a:ea typeface="Arial" pitchFamily="34" charset="-122"/>
+                <a:cs typeface="Arial" pitchFamily="34" charset="-120"/>
+              </a:rPr>
+              <a:t>Cronograma: de la aprobación al despliegue</a:t>
+            </a:r>
+            <a:endParaRPr lang="en-US" sz="2800" dirty="0"/>
+          </a:p>
+        </p:txBody>
+      </p:sp>
+      <p:sp>
+        <p:nvSpPr>
+          <p:cNvPr id="3" name="Text 1"/>
+          <p:cNvSpPr txBox="1"/>
+          <p:nvPr/>
+        </p:nvSpPr>
+        <p:spPr>
+          <a:xfrm>
+            <a:off x="8778240" y="457200"/>
+            <a:ext cx="2862072" cy="365760"/>
+          </a:xfrm>
+          <a:prstGeom prst="rect">
+            <a:avLst/>
+          </a:prstGeom>
+          <a:noFill/>
+          <a:ln/>
+        </p:spPr>
+        <p:txBody>
+          <a:bodyPr wrap="square" lIns="0" tIns="0" rIns="0" bIns="0" rtlCol="0" anchor="ctr"/>
+          <a:lstStyle/>
+          <a:p>
+            <a:pPr algn="r" indent="0" marL="0">
+              <a:buNone/>
+            </a:pPr>
+            <a:r>
+              <a:rPr lang="en-US" sz="1000" b="1" spc="200" kern="0" dirty="0">
+                <a:solidFill>
+                  <a:srgbClr val="6B7280"/>
+                </a:solidFill>
+                <a:latin typeface="Arial" pitchFamily="34" charset="0"/>
+                <a:ea typeface="Arial" pitchFamily="34" charset="-122"/>
+                <a:cs typeface="Arial" pitchFamily="34" charset="-120"/>
+              </a:rPr>
+              <a:t>STELLANTIS  ·  UNIDAD PINTURA</a:t>
+            </a:r>
+            <a:endParaRPr lang="en-US" sz="1000" dirty="0"/>
+          </a:p>
+        </p:txBody>
+      </p:sp>
+      <p:sp>
+        <p:nvSpPr>
+          <p:cNvPr id="4" name="Shape 2"/>
+          <p:cNvSpPr/>
+          <p:nvPr/>
+        </p:nvSpPr>
+        <p:spPr>
+          <a:xfrm>
+            <a:off x="7695174" y="1783080"/>
+            <a:ext cx="682812" cy="4197096"/>
+          </a:xfrm>
+          <a:prstGeom prst="rect">
+            <a:avLst/>
+          </a:prstGeom>
+          <a:solidFill>
+            <a:srgbClr val="D9E0EA"/>
+          </a:solidFill>
+          <a:ln w="12700">
+            <a:solidFill>
+              <a:srgbClr val="D9E0EA"/>
+            </a:solidFill>
+            <a:prstDash val="solid"/>
+          </a:ln>
+        </p:spPr>
+      </p:sp>
+      <p:sp>
+        <p:nvSpPr>
+          <p:cNvPr id="5" name="Text 3"/>
+          <p:cNvSpPr txBox="1"/>
+          <p:nvPr/>
+        </p:nvSpPr>
+        <p:spPr>
+          <a:xfrm>
+            <a:off x="7512294" y="5998464"/>
+            <a:ext cx="1048572" cy="201168"/>
+          </a:xfrm>
+          <a:prstGeom prst="rect">
+            <a:avLst/>
+          </a:prstGeom>
+          <a:noFill/>
+          <a:ln/>
+        </p:spPr>
+        <p:txBody>
+          <a:bodyPr wrap="square" lIns="0" tIns="0" rIns="0" bIns="0" rtlCol="0" anchor="ctr"/>
+          <a:lstStyle/>
+          <a:p>
+            <a:pPr algn="ctr" indent="0" marL="0">
+              <a:buNone/>
+            </a:pPr>
+            <a:r>
+              <a:rPr lang="en-US" sz="800" dirty="0">
+                <a:solidFill>
+                  <a:srgbClr val="6B7280"/>
+                </a:solidFill>
+                <a:latin typeface="Arial" pitchFamily="34" charset="0"/>
+                <a:ea typeface="Arial" pitchFamily="34" charset="-122"/>
+                <a:cs typeface="Arial" pitchFamily="34" charset="-120"/>
+              </a:rPr>
+              <a:t>Receso</a:t>
+            </a:r>
+            <a:endParaRPr lang="en-US" sz="800" dirty="0"/>
+          </a:p>
+        </p:txBody>
+      </p:sp>
+      <p:sp>
+        <p:nvSpPr>
+          <p:cNvPr id="6" name="Shape 4"/>
+          <p:cNvSpPr/>
+          <p:nvPr/>
+        </p:nvSpPr>
+        <p:spPr>
+          <a:xfrm>
+            <a:off x="3977640" y="1399032"/>
+            <a:ext cx="644878" cy="329184"/>
+          </a:xfrm>
+          <a:prstGeom prst="rect">
+            <a:avLst/>
+          </a:prstGeom>
+          <a:solidFill>
+            <a:srgbClr val="F3F5F8"/>
+          </a:solidFill>
+          <a:ln w="12700">
+            <a:solidFill>
+              <a:srgbClr val="FFFFFF"/>
+            </a:solidFill>
+            <a:prstDash val="solid"/>
+          </a:ln>
+        </p:spPr>
+      </p:sp>
+      <p:sp>
+        <p:nvSpPr>
+          <p:cNvPr id="7" name="Text 5"/>
+          <p:cNvSpPr txBox="1"/>
+          <p:nvPr/>
+        </p:nvSpPr>
+        <p:spPr>
+          <a:xfrm>
+            <a:off x="3977640" y="1399032"/>
+            <a:ext cx="644878" cy="329184"/>
+          </a:xfrm>
+          <a:prstGeom prst="rect">
+            <a:avLst/>
+          </a:prstGeom>
+          <a:noFill/>
+          <a:ln/>
+        </p:spPr>
+        <p:txBody>
+          <a:bodyPr wrap="square" lIns="0" tIns="0" rIns="0" bIns="0" rtlCol="0" anchor="ctr"/>
+          <a:lstStyle/>
+          <a:p>
+            <a:pPr algn="ctr" indent="0" marL="0">
+              <a:buNone/>
+            </a:pPr>
+            <a:r>
+              <a:rPr lang="en-US" sz="1000" b="1" dirty="0">
+                <a:solidFill>
+                  <a:srgbClr val="022A5B"/>
+                </a:solidFill>
+                <a:latin typeface="Arial" pitchFamily="34" charset="0"/>
+                <a:ea typeface="Arial" pitchFamily="34" charset="-122"/>
+                <a:cs typeface="Arial" pitchFamily="34" charset="-120"/>
+              </a:rPr>
+              <a:t>Sep</a:t>
+            </a:r>
+            <a:endParaRPr lang="en-US" sz="1000" dirty="0"/>
+          </a:p>
+        </p:txBody>
+      </p:sp>
+      <p:sp>
+        <p:nvSpPr>
+          <p:cNvPr id="8" name="Shape 6"/>
+          <p:cNvSpPr/>
+          <p:nvPr/>
+        </p:nvSpPr>
+        <p:spPr>
+          <a:xfrm>
+            <a:off x="3977640" y="1783080"/>
+            <a:ext cx="0" cy="4197096"/>
+          </a:xfrm>
+          <a:prstGeom prst="line">
+            <a:avLst/>
+          </a:prstGeom>
+          <a:noFill/>
+          <a:ln w="9525">
+            <a:solidFill>
+              <a:srgbClr val="D9E0EA"/>
+            </a:solidFill>
+            <a:prstDash val="solid"/>
+          </a:ln>
+        </p:spPr>
+      </p:sp>
+      <p:sp>
+        <p:nvSpPr>
+          <p:cNvPr id="9" name="Shape 7"/>
+          <p:cNvSpPr/>
+          <p:nvPr/>
+        </p:nvSpPr>
+        <p:spPr>
+          <a:xfrm>
+            <a:off x="4622518" y="1399032"/>
+            <a:ext cx="1175955" cy="329184"/>
+          </a:xfrm>
+          <a:prstGeom prst="rect">
+            <a:avLst/>
+          </a:prstGeom>
+          <a:solidFill>
+            <a:srgbClr val="F3F5F8"/>
+          </a:solidFill>
+          <a:ln w="12700">
+            <a:solidFill>
+              <a:srgbClr val="FFFFFF"/>
+            </a:solidFill>
+            <a:prstDash val="solid"/>
+          </a:ln>
+        </p:spPr>
+      </p:sp>
+      <p:sp>
+        <p:nvSpPr>
+          <p:cNvPr id="10" name="Text 8"/>
+          <p:cNvSpPr txBox="1"/>
+          <p:nvPr/>
+        </p:nvSpPr>
+        <p:spPr>
+          <a:xfrm>
+            <a:off x="4622518" y="1399032"/>
+            <a:ext cx="1175955" cy="329184"/>
+          </a:xfrm>
+          <a:prstGeom prst="rect">
+            <a:avLst/>
+          </a:prstGeom>
+          <a:noFill/>
+          <a:ln/>
+        </p:spPr>
+        <p:txBody>
+          <a:bodyPr wrap="square" lIns="0" tIns="0" rIns="0" bIns="0" rtlCol="0" anchor="ctr"/>
+          <a:lstStyle/>
+          <a:p>
+            <a:pPr algn="ctr" indent="0" marL="0">
+              <a:buNone/>
+            </a:pPr>
+            <a:r>
+              <a:rPr lang="en-US" sz="1000" b="1" dirty="0">
+                <a:solidFill>
+                  <a:srgbClr val="022A5B"/>
+                </a:solidFill>
+                <a:latin typeface="Arial" pitchFamily="34" charset="0"/>
+                <a:ea typeface="Arial" pitchFamily="34" charset="-122"/>
+                <a:cs typeface="Arial" pitchFamily="34" charset="-120"/>
+              </a:rPr>
+              <a:t>Oct</a:t>
+            </a:r>
+            <a:endParaRPr lang="en-US" sz="1000" dirty="0"/>
+          </a:p>
+        </p:txBody>
+      </p:sp>
+      <p:sp>
+        <p:nvSpPr>
+          <p:cNvPr id="11" name="Shape 9"/>
+          <p:cNvSpPr/>
+          <p:nvPr/>
+        </p:nvSpPr>
+        <p:spPr>
+          <a:xfrm>
+            <a:off x="4622518" y="1783080"/>
+            <a:ext cx="0" cy="4197096"/>
+          </a:xfrm>
+          <a:prstGeom prst="line">
+            <a:avLst/>
+          </a:prstGeom>
+          <a:noFill/>
+          <a:ln w="9525">
+            <a:solidFill>
+              <a:srgbClr val="D9E0EA"/>
+            </a:solidFill>
+            <a:prstDash val="solid"/>
+          </a:ln>
+        </p:spPr>
+      </p:sp>
+      <p:sp>
+        <p:nvSpPr>
+          <p:cNvPr id="12" name="Shape 10"/>
+          <p:cNvSpPr/>
+          <p:nvPr/>
+        </p:nvSpPr>
+        <p:spPr>
+          <a:xfrm>
+            <a:off x="5798473" y="1399032"/>
+            <a:ext cx="1138021" cy="329184"/>
+          </a:xfrm>
+          <a:prstGeom prst="rect">
+            <a:avLst/>
+          </a:prstGeom>
+          <a:solidFill>
+            <a:srgbClr val="F3F5F8"/>
+          </a:solidFill>
+          <a:ln w="12700">
+            <a:solidFill>
+              <a:srgbClr val="FFFFFF"/>
+            </a:solidFill>
+            <a:prstDash val="solid"/>
+          </a:ln>
+        </p:spPr>
+      </p:sp>
+      <p:sp>
+        <p:nvSpPr>
+          <p:cNvPr id="13" name="Text 11"/>
+          <p:cNvSpPr txBox="1"/>
+          <p:nvPr/>
+        </p:nvSpPr>
+        <p:spPr>
+          <a:xfrm>
+            <a:off x="5798473" y="1399032"/>
+            <a:ext cx="1138021" cy="329184"/>
+          </a:xfrm>
+          <a:prstGeom prst="rect">
+            <a:avLst/>
+          </a:prstGeom>
+          <a:noFill/>
+          <a:ln/>
+        </p:spPr>
+        <p:txBody>
+          <a:bodyPr wrap="square" lIns="0" tIns="0" rIns="0" bIns="0" rtlCol="0" anchor="ctr"/>
+          <a:lstStyle/>
+          <a:p>
+            <a:pPr algn="ctr" indent="0" marL="0">
+              <a:buNone/>
+            </a:pPr>
+            <a:r>
+              <a:rPr lang="en-US" sz="1000" b="1" dirty="0">
+                <a:solidFill>
+                  <a:srgbClr val="022A5B"/>
+                </a:solidFill>
+                <a:latin typeface="Arial" pitchFamily="34" charset="0"/>
+                <a:ea typeface="Arial" pitchFamily="34" charset="-122"/>
+                <a:cs typeface="Arial" pitchFamily="34" charset="-120"/>
+              </a:rPr>
+              <a:t>Nov</a:t>
+            </a:r>
+            <a:endParaRPr lang="en-US" sz="1000" dirty="0"/>
+          </a:p>
+        </p:txBody>
+      </p:sp>
+      <p:sp>
+        <p:nvSpPr>
+          <p:cNvPr id="14" name="Shape 12"/>
+          <p:cNvSpPr/>
+          <p:nvPr/>
+        </p:nvSpPr>
+        <p:spPr>
+          <a:xfrm>
+            <a:off x="5798473" y="1783080"/>
+            <a:ext cx="0" cy="4197096"/>
+          </a:xfrm>
+          <a:prstGeom prst="line">
+            <a:avLst/>
+          </a:prstGeom>
+          <a:noFill/>
+          <a:ln w="9525">
+            <a:solidFill>
+              <a:srgbClr val="D9E0EA"/>
+            </a:solidFill>
+            <a:prstDash val="solid"/>
+          </a:ln>
+        </p:spPr>
+      </p:sp>
+      <p:sp>
+        <p:nvSpPr>
+          <p:cNvPr id="15" name="Shape 13"/>
+          <p:cNvSpPr/>
+          <p:nvPr/>
+        </p:nvSpPr>
+        <p:spPr>
+          <a:xfrm>
+            <a:off x="6936494" y="1399032"/>
+            <a:ext cx="1175955" cy="329184"/>
+          </a:xfrm>
+          <a:prstGeom prst="rect">
+            <a:avLst/>
+          </a:prstGeom>
+          <a:solidFill>
+            <a:srgbClr val="F3F5F8"/>
+          </a:solidFill>
+          <a:ln w="12700">
+            <a:solidFill>
+              <a:srgbClr val="FFFFFF"/>
+            </a:solidFill>
+            <a:prstDash val="solid"/>
+          </a:ln>
+        </p:spPr>
+      </p:sp>
+      <p:sp>
+        <p:nvSpPr>
+          <p:cNvPr id="16" name="Text 14"/>
+          <p:cNvSpPr txBox="1"/>
+          <p:nvPr/>
+        </p:nvSpPr>
+        <p:spPr>
+          <a:xfrm>
+            <a:off x="6936494" y="1399032"/>
+            <a:ext cx="1175955" cy="329184"/>
+          </a:xfrm>
+          <a:prstGeom prst="rect">
+            <a:avLst/>
+          </a:prstGeom>
+          <a:noFill/>
+          <a:ln/>
+        </p:spPr>
+        <p:txBody>
+          <a:bodyPr wrap="square" lIns="0" tIns="0" rIns="0" bIns="0" rtlCol="0" anchor="ctr"/>
+          <a:lstStyle/>
+          <a:p>
+            <a:pPr algn="ctr" indent="0" marL="0">
+              <a:buNone/>
+            </a:pPr>
+            <a:r>
+              <a:rPr lang="en-US" sz="1000" b="1" dirty="0">
+                <a:solidFill>
+                  <a:srgbClr val="022A5B"/>
+                </a:solidFill>
+                <a:latin typeface="Arial" pitchFamily="34" charset="0"/>
+                <a:ea typeface="Arial" pitchFamily="34" charset="-122"/>
+                <a:cs typeface="Arial" pitchFamily="34" charset="-120"/>
+              </a:rPr>
+              <a:t>Dic</a:t>
+            </a:r>
+            <a:endParaRPr lang="en-US" sz="1000" dirty="0"/>
+          </a:p>
+        </p:txBody>
+      </p:sp>
+      <p:sp>
+        <p:nvSpPr>
+          <p:cNvPr id="17" name="Shape 15"/>
+          <p:cNvSpPr/>
+          <p:nvPr/>
+        </p:nvSpPr>
+        <p:spPr>
+          <a:xfrm>
+            <a:off x="6936494" y="1783080"/>
+            <a:ext cx="0" cy="4197096"/>
+          </a:xfrm>
+          <a:prstGeom prst="line">
+            <a:avLst/>
+          </a:prstGeom>
+          <a:noFill/>
+          <a:ln w="9525">
+            <a:solidFill>
+              <a:srgbClr val="D9E0EA"/>
+            </a:solidFill>
+            <a:prstDash val="solid"/>
+          </a:ln>
+        </p:spPr>
+      </p:sp>
+      <p:sp>
+        <p:nvSpPr>
+          <p:cNvPr id="18" name="Shape 16"/>
+          <p:cNvSpPr/>
+          <p:nvPr/>
+        </p:nvSpPr>
+        <p:spPr>
+          <a:xfrm>
+            <a:off x="8112448" y="1399032"/>
+            <a:ext cx="1175955" cy="329184"/>
+          </a:xfrm>
+          <a:prstGeom prst="rect">
+            <a:avLst/>
+          </a:prstGeom>
+          <a:solidFill>
+            <a:srgbClr val="F3F5F8"/>
+          </a:solidFill>
+          <a:ln w="12700">
+            <a:solidFill>
+              <a:srgbClr val="FFFFFF"/>
+            </a:solidFill>
+            <a:prstDash val="solid"/>
+          </a:ln>
+        </p:spPr>
+      </p:sp>
+      <p:sp>
+        <p:nvSpPr>
+          <p:cNvPr id="19" name="Text 17"/>
+          <p:cNvSpPr txBox="1"/>
+          <p:nvPr/>
+        </p:nvSpPr>
+        <p:spPr>
+          <a:xfrm>
+            <a:off x="8112448" y="1399032"/>
+            <a:ext cx="1175955" cy="329184"/>
+          </a:xfrm>
+          <a:prstGeom prst="rect">
+            <a:avLst/>
+          </a:prstGeom>
+          <a:noFill/>
+          <a:ln/>
+        </p:spPr>
+        <p:txBody>
+          <a:bodyPr wrap="square" lIns="0" tIns="0" rIns="0" bIns="0" rtlCol="0" anchor="ctr"/>
+          <a:lstStyle/>
+          <a:p>
+            <a:pPr algn="ctr" indent="0" marL="0">
+              <a:buNone/>
+            </a:pPr>
+            <a:r>
+              <a:rPr lang="en-US" sz="1000" b="1" dirty="0">
+                <a:solidFill>
+                  <a:srgbClr val="022A5B"/>
+                </a:solidFill>
+                <a:latin typeface="Arial" pitchFamily="34" charset="0"/>
+                <a:ea typeface="Arial" pitchFamily="34" charset="-122"/>
+                <a:cs typeface="Arial" pitchFamily="34" charset="-120"/>
+              </a:rPr>
+              <a:t>Ene 2027</a:t>
+            </a:r>
+            <a:endParaRPr lang="en-US" sz="1000" dirty="0"/>
+          </a:p>
+        </p:txBody>
+      </p:sp>
+      <p:sp>
+        <p:nvSpPr>
+          <p:cNvPr id="20" name="Shape 18"/>
+          <p:cNvSpPr/>
+          <p:nvPr/>
+        </p:nvSpPr>
+        <p:spPr>
+          <a:xfrm>
+            <a:off x="8112448" y="1783080"/>
+            <a:ext cx="0" cy="4197096"/>
+          </a:xfrm>
+          <a:prstGeom prst="line">
+            <a:avLst/>
+          </a:prstGeom>
+          <a:noFill/>
+          <a:ln w="9525">
+            <a:solidFill>
+              <a:srgbClr val="D9E0EA"/>
+            </a:solidFill>
+            <a:prstDash val="solid"/>
+          </a:ln>
+        </p:spPr>
+      </p:sp>
+      <p:sp>
+        <p:nvSpPr>
+          <p:cNvPr id="21" name="Shape 19"/>
+          <p:cNvSpPr/>
+          <p:nvPr/>
+        </p:nvSpPr>
+        <p:spPr>
+          <a:xfrm>
+            <a:off x="9288403" y="1399032"/>
+            <a:ext cx="1062153" cy="329184"/>
+          </a:xfrm>
+          <a:prstGeom prst="rect">
+            <a:avLst/>
+          </a:prstGeom>
+          <a:solidFill>
+            <a:srgbClr val="F3F5F8"/>
+          </a:solidFill>
+          <a:ln w="12700">
+            <a:solidFill>
+              <a:srgbClr val="FFFFFF"/>
+            </a:solidFill>
+            <a:prstDash val="solid"/>
+          </a:ln>
+        </p:spPr>
+      </p:sp>
+      <p:sp>
+        <p:nvSpPr>
+          <p:cNvPr id="22" name="Text 20"/>
+          <p:cNvSpPr txBox="1"/>
+          <p:nvPr/>
+        </p:nvSpPr>
+        <p:spPr>
+          <a:xfrm>
+            <a:off x="9288403" y="1399032"/>
+            <a:ext cx="1062153" cy="329184"/>
+          </a:xfrm>
+          <a:prstGeom prst="rect">
+            <a:avLst/>
+          </a:prstGeom>
+          <a:noFill/>
+          <a:ln/>
+        </p:spPr>
+        <p:txBody>
+          <a:bodyPr wrap="square" lIns="0" tIns="0" rIns="0" bIns="0" rtlCol="0" anchor="ctr"/>
+          <a:lstStyle/>
+          <a:p>
+            <a:pPr algn="ctr" indent="0" marL="0">
+              <a:buNone/>
+            </a:pPr>
+            <a:r>
+              <a:rPr lang="en-US" sz="1000" b="1" dirty="0">
+                <a:solidFill>
+                  <a:srgbClr val="022A5B"/>
+                </a:solidFill>
+                <a:latin typeface="Arial" pitchFamily="34" charset="0"/>
+                <a:ea typeface="Arial" pitchFamily="34" charset="-122"/>
+                <a:cs typeface="Arial" pitchFamily="34" charset="-120"/>
+              </a:rPr>
+              <a:t>Feb</a:t>
+            </a:r>
+            <a:endParaRPr lang="en-US" sz="1000" dirty="0"/>
+          </a:p>
+        </p:txBody>
+      </p:sp>
+      <p:sp>
+        <p:nvSpPr>
+          <p:cNvPr id="23" name="Shape 21"/>
+          <p:cNvSpPr/>
+          <p:nvPr/>
+        </p:nvSpPr>
+        <p:spPr>
+          <a:xfrm>
+            <a:off x="9288403" y="1783080"/>
+            <a:ext cx="0" cy="4197096"/>
+          </a:xfrm>
+          <a:prstGeom prst="line">
+            <a:avLst/>
+          </a:prstGeom>
+          <a:noFill/>
+          <a:ln w="9525">
+            <a:solidFill>
+              <a:srgbClr val="D9E0EA"/>
+            </a:solidFill>
+            <a:prstDash val="solid"/>
+          </a:ln>
+        </p:spPr>
+      </p:sp>
+      <p:sp>
+        <p:nvSpPr>
+          <p:cNvPr id="24" name="Shape 22"/>
+          <p:cNvSpPr/>
+          <p:nvPr/>
+        </p:nvSpPr>
+        <p:spPr>
+          <a:xfrm>
+            <a:off x="10350555" y="1399032"/>
+            <a:ext cx="1175955" cy="329184"/>
+          </a:xfrm>
+          <a:prstGeom prst="rect">
+            <a:avLst/>
+          </a:prstGeom>
+          <a:solidFill>
+            <a:srgbClr val="F3F5F8"/>
+          </a:solidFill>
+          <a:ln w="12700">
+            <a:solidFill>
+              <a:srgbClr val="FFFFFF"/>
+            </a:solidFill>
+            <a:prstDash val="solid"/>
+          </a:ln>
+        </p:spPr>
+      </p:sp>
+      <p:sp>
+        <p:nvSpPr>
+          <p:cNvPr id="25" name="Text 23"/>
+          <p:cNvSpPr txBox="1"/>
+          <p:nvPr/>
+        </p:nvSpPr>
+        <p:spPr>
+          <a:xfrm>
+            <a:off x="10350555" y="1399032"/>
+            <a:ext cx="1175955" cy="329184"/>
+          </a:xfrm>
+          <a:prstGeom prst="rect">
+            <a:avLst/>
+          </a:prstGeom>
+          <a:noFill/>
+          <a:ln/>
+        </p:spPr>
+        <p:txBody>
+          <a:bodyPr wrap="square" lIns="0" tIns="0" rIns="0" bIns="0" rtlCol="0" anchor="ctr"/>
+          <a:lstStyle/>
+          <a:p>
+            <a:pPr algn="ctr" indent="0" marL="0">
+              <a:buNone/>
+            </a:pPr>
+            <a:r>
+              <a:rPr lang="en-US" sz="1000" b="1" dirty="0">
+                <a:solidFill>
+                  <a:srgbClr val="022A5B"/>
+                </a:solidFill>
+                <a:latin typeface="Arial" pitchFamily="34" charset="0"/>
+                <a:ea typeface="Arial" pitchFamily="34" charset="-122"/>
+                <a:cs typeface="Arial" pitchFamily="34" charset="-120"/>
+              </a:rPr>
+              <a:t>Mar</a:t>
+            </a:r>
+            <a:endParaRPr lang="en-US" sz="1000" dirty="0"/>
+          </a:p>
+        </p:txBody>
+      </p:sp>
+      <p:sp>
+        <p:nvSpPr>
+          <p:cNvPr id="26" name="Shape 24"/>
+          <p:cNvSpPr/>
+          <p:nvPr/>
+        </p:nvSpPr>
+        <p:spPr>
+          <a:xfrm>
+            <a:off x="10350555" y="1783080"/>
+            <a:ext cx="0" cy="4197096"/>
+          </a:xfrm>
+          <a:prstGeom prst="line">
+            <a:avLst/>
+          </a:prstGeom>
+          <a:noFill/>
+          <a:ln w="9525">
+            <a:solidFill>
+              <a:srgbClr val="D9E0EA"/>
+            </a:solidFill>
+            <a:prstDash val="solid"/>
+          </a:ln>
+        </p:spPr>
+      </p:sp>
+      <p:sp>
+        <p:nvSpPr>
+          <p:cNvPr id="27" name="Shape 25"/>
+          <p:cNvSpPr/>
+          <p:nvPr/>
+        </p:nvSpPr>
+        <p:spPr>
+          <a:xfrm>
+            <a:off x="11526510" y="1399032"/>
+            <a:ext cx="113802" cy="329184"/>
+          </a:xfrm>
+          <a:prstGeom prst="rect">
+            <a:avLst/>
+          </a:prstGeom>
+          <a:solidFill>
+            <a:srgbClr val="F3F5F8"/>
+          </a:solidFill>
+          <a:ln w="12700">
+            <a:solidFill>
+              <a:srgbClr val="FFFFFF"/>
+            </a:solidFill>
+            <a:prstDash val="solid"/>
+          </a:ln>
+        </p:spPr>
+      </p:sp>
+      <p:sp>
+        <p:nvSpPr>
+          <p:cNvPr id="28" name="Shape 26"/>
+          <p:cNvSpPr/>
+          <p:nvPr/>
+        </p:nvSpPr>
+        <p:spPr>
+          <a:xfrm>
+            <a:off x="11526510" y="1783080"/>
+            <a:ext cx="0" cy="4197096"/>
+          </a:xfrm>
+          <a:prstGeom prst="line">
+            <a:avLst/>
+          </a:prstGeom>
+          <a:noFill/>
+          <a:ln w="9525">
+            <a:solidFill>
+              <a:srgbClr val="D9E0EA"/>
+            </a:solidFill>
+            <a:prstDash val="solid"/>
+          </a:ln>
+        </p:spPr>
+      </p:sp>
+      <p:sp>
+        <p:nvSpPr>
+          <p:cNvPr id="29" name="Text 27"/>
+          <p:cNvSpPr txBox="1"/>
+          <p:nvPr/>
+        </p:nvSpPr>
+        <p:spPr>
+          <a:xfrm>
+            <a:off x="3977640" y="1143000"/>
+            <a:ext cx="1828800" cy="228600"/>
+          </a:xfrm>
+          <a:prstGeom prst="rect">
+            <a:avLst/>
+          </a:prstGeom>
+          <a:noFill/>
+          <a:ln/>
+        </p:spPr>
+        <p:txBody>
+          <a:bodyPr wrap="square" lIns="0" tIns="0" rIns="0" bIns="0" rtlCol="0" anchor="ctr"/>
+          <a:lstStyle/>
+          <a:p>
+            <a:pPr indent="0" marL="0">
+              <a:buNone/>
+            </a:pPr>
+            <a:r>
+              <a:rPr lang="en-US" sz="900" b="1" dirty="0">
+                <a:solidFill>
+                  <a:srgbClr val="6B7280"/>
+                </a:solidFill>
+                <a:latin typeface="Arial" pitchFamily="34" charset="0"/>
+                <a:ea typeface="Arial" pitchFamily="34" charset="-122"/>
+                <a:cs typeface="Arial" pitchFamily="34" charset="-120"/>
+              </a:rPr>
+              <a:t>2026</a:t>
+            </a:r>
+            <a:endParaRPr lang="en-US" sz="900" dirty="0"/>
+          </a:p>
+        </p:txBody>
+      </p:sp>
+      <p:sp>
+        <p:nvSpPr>
+          <p:cNvPr id="30" name="Text 28"/>
+          <p:cNvSpPr txBox="1"/>
+          <p:nvPr/>
+        </p:nvSpPr>
+        <p:spPr>
+          <a:xfrm>
+            <a:off x="8112448" y="1143000"/>
+            <a:ext cx="1828800" cy="228600"/>
+          </a:xfrm>
+          <a:prstGeom prst="rect">
+            <a:avLst/>
+          </a:prstGeom>
+          <a:noFill/>
+          <a:ln/>
+        </p:spPr>
+        <p:txBody>
+          <a:bodyPr wrap="square" lIns="0" tIns="0" rIns="0" bIns="0" rtlCol="0" anchor="ctr"/>
+          <a:lstStyle/>
+          <a:p>
+            <a:pPr indent="0" marL="0">
+              <a:buNone/>
+            </a:pPr>
+            <a:r>
+              <a:rPr lang="en-US" sz="900" b="1" dirty="0">
+                <a:solidFill>
+                  <a:srgbClr val="6B7280"/>
+                </a:solidFill>
+                <a:latin typeface="Arial" pitchFamily="34" charset="0"/>
+                <a:ea typeface="Arial" pitchFamily="34" charset="-122"/>
+                <a:cs typeface="Arial" pitchFamily="34" charset="-120"/>
+              </a:rPr>
+              <a:t>2027</a:t>
+            </a:r>
+            <a:endParaRPr lang="en-US" sz="900" dirty="0"/>
+          </a:p>
+        </p:txBody>
+      </p:sp>
+      <p:sp>
+        <p:nvSpPr>
+          <p:cNvPr id="31" name="Shape 29"/>
+          <p:cNvSpPr/>
+          <p:nvPr/>
+        </p:nvSpPr>
+        <p:spPr>
+          <a:xfrm>
+            <a:off x="548640" y="1783080"/>
+            <a:ext cx="11091672" cy="246888"/>
+          </a:xfrm>
+          <a:prstGeom prst="rect">
+            <a:avLst/>
+          </a:prstGeom>
+          <a:solidFill>
+            <a:srgbClr val="F3F5F8"/>
+          </a:solidFill>
+          <a:ln w="12700">
+            <a:solidFill>
+              <a:srgbClr val="F3F5F8"/>
+            </a:solidFill>
+            <a:prstDash val="solid"/>
+          </a:ln>
+        </p:spPr>
+      </p:sp>
+      <p:sp>
+        <p:nvSpPr>
+          <p:cNvPr id="32" name="Text 30"/>
+          <p:cNvSpPr txBox="1"/>
+          <p:nvPr/>
+        </p:nvSpPr>
+        <p:spPr>
+          <a:xfrm>
+            <a:off x="640080" y="1783080"/>
+            <a:ext cx="3017520" cy="246888"/>
+          </a:xfrm>
+          <a:prstGeom prst="rect">
+            <a:avLst/>
+          </a:prstGeom>
+          <a:noFill/>
+          <a:ln/>
+        </p:spPr>
+        <p:txBody>
+          <a:bodyPr wrap="square" lIns="0" tIns="0" rIns="0" bIns="0" rtlCol="0" anchor="ctr"/>
+          <a:lstStyle/>
+          <a:p>
+            <a:pPr indent="0" marL="0">
+              <a:buNone/>
+            </a:pPr>
+            <a:r>
+              <a:rPr lang="en-US" sz="950" b="1" dirty="0">
+                <a:solidFill>
+                  <a:srgbClr val="022A5B"/>
+                </a:solidFill>
+                <a:latin typeface="Arial" pitchFamily="34" charset="0"/>
+                <a:ea typeface="Arial" pitchFamily="34" charset="-122"/>
+                <a:cs typeface="Arial" pitchFamily="34" charset="-120"/>
+              </a:rPr>
+              <a:t>FASE 1 · Diseño</a:t>
+            </a:r>
+            <a:endParaRPr lang="en-US" sz="950" dirty="0"/>
+          </a:p>
+        </p:txBody>
+      </p:sp>
+      <p:sp>
+        <p:nvSpPr>
+          <p:cNvPr id="33" name="Shape 31"/>
+          <p:cNvSpPr/>
+          <p:nvPr/>
+        </p:nvSpPr>
+        <p:spPr>
+          <a:xfrm>
+            <a:off x="3977640" y="1847088"/>
+            <a:ext cx="948350" cy="118872"/>
+          </a:xfrm>
+          <a:prstGeom prst="rect">
+            <a:avLst/>
+          </a:prstGeom>
+          <a:solidFill>
+            <a:srgbClr val="022A5B"/>
+          </a:solidFill>
+          <a:ln w="12700">
+            <a:solidFill>
+              <a:srgbClr val="022A5B"/>
+            </a:solidFill>
+            <a:prstDash val="solid"/>
+          </a:ln>
+        </p:spPr>
+      </p:sp>
+      <p:sp>
+        <p:nvSpPr>
+          <p:cNvPr id="34" name="Text 32"/>
+          <p:cNvSpPr txBox="1"/>
+          <p:nvPr/>
+        </p:nvSpPr>
+        <p:spPr>
+          <a:xfrm>
+            <a:off x="3063240" y="1783080"/>
+            <a:ext cx="868680" cy="246888"/>
+          </a:xfrm>
+          <a:prstGeom prst="rect">
+            <a:avLst/>
+          </a:prstGeom>
+          <a:noFill/>
+          <a:ln/>
+        </p:spPr>
+        <p:txBody>
+          <a:bodyPr wrap="square" lIns="0" tIns="0" rIns="0" bIns="0" rtlCol="0" anchor="ctr"/>
+          <a:lstStyle/>
+          <a:p>
+            <a:pPr algn="r" indent="0" marL="0">
+              <a:buNone/>
+            </a:pPr>
+            <a:r>
+              <a:rPr lang="en-US" sz="750" dirty="0">
+                <a:solidFill>
+                  <a:srgbClr val="6B7280"/>
+                </a:solidFill>
+                <a:latin typeface="Arial" pitchFamily="34" charset="0"/>
+                <a:ea typeface="Arial" pitchFamily="34" charset="-122"/>
+                <a:cs typeface="Arial" pitchFamily="34" charset="-120"/>
+              </a:rPr>
+              <a:t>14/09 – 09/10</a:t>
+            </a:r>
+            <a:endParaRPr lang="en-US" sz="750" dirty="0"/>
+          </a:p>
+        </p:txBody>
+      </p:sp>
+      <p:sp>
+        <p:nvSpPr>
+          <p:cNvPr id="35" name="Text 33"/>
+          <p:cNvSpPr txBox="1"/>
+          <p:nvPr/>
+        </p:nvSpPr>
+        <p:spPr>
+          <a:xfrm>
+            <a:off x="868680" y="2029968"/>
+            <a:ext cx="3017520" cy="246888"/>
+          </a:xfrm>
+          <a:prstGeom prst="rect">
+            <a:avLst/>
+          </a:prstGeom>
+          <a:noFill/>
+          <a:ln/>
+        </p:spPr>
+        <p:txBody>
+          <a:bodyPr wrap="square" lIns="0" tIns="0" rIns="0" bIns="0" rtlCol="0" anchor="ctr"/>
+          <a:lstStyle/>
+          <a:p>
+            <a:pPr indent="0" marL="0">
+              <a:buNone/>
+            </a:pPr>
+            <a:r>
+              <a:rPr lang="en-US" sz="900" dirty="0">
+                <a:solidFill>
+                  <a:srgbClr val="1F2937"/>
+                </a:solidFill>
+                <a:latin typeface="Arial" pitchFamily="34" charset="0"/>
+                <a:ea typeface="Arial" pitchFamily="34" charset="-122"/>
+                <a:cs typeface="Arial" pitchFamily="34" charset="-120"/>
+              </a:rPr>
+              <a:t>Definir el espacio físico y el layout</a:t>
+            </a:r>
+            <a:endParaRPr lang="en-US" sz="900" dirty="0"/>
+          </a:p>
+        </p:txBody>
+      </p:sp>
+      <p:sp>
+        <p:nvSpPr>
+          <p:cNvPr id="36" name="Shape 34"/>
+          <p:cNvSpPr/>
+          <p:nvPr/>
+        </p:nvSpPr>
+        <p:spPr>
+          <a:xfrm>
+            <a:off x="3977640" y="2075688"/>
+            <a:ext cx="417274" cy="155448"/>
+          </a:xfrm>
+          <a:prstGeom prst="roundRect">
+            <a:avLst>
+              <a:gd name="adj" fmla="val 29412"/>
+            </a:avLst>
+          </a:prstGeom>
+          <a:solidFill>
+            <a:srgbClr val="022A5B">
+              <a:alpha val="55000"/>
+            </a:srgbClr>
+          </a:solidFill>
+          <a:ln w="9525">
+            <a:solidFill>
+              <a:srgbClr val="022A5B"/>
+            </a:solidFill>
+            <a:prstDash val="solid"/>
+          </a:ln>
+        </p:spPr>
+      </p:sp>
+      <p:sp>
+        <p:nvSpPr>
+          <p:cNvPr id="37" name="Text 35"/>
+          <p:cNvSpPr txBox="1"/>
+          <p:nvPr/>
+        </p:nvSpPr>
+        <p:spPr>
+          <a:xfrm>
+            <a:off x="3063240" y="2029968"/>
+            <a:ext cx="868680" cy="246888"/>
+          </a:xfrm>
+          <a:prstGeom prst="rect">
+            <a:avLst/>
+          </a:prstGeom>
+          <a:noFill/>
+          <a:ln/>
+        </p:spPr>
+        <p:txBody>
+          <a:bodyPr wrap="square" lIns="0" tIns="0" rIns="0" bIns="0" rtlCol="0" anchor="ctr"/>
+          <a:lstStyle/>
+          <a:p>
+            <a:pPr algn="r" indent="0" marL="0">
+              <a:buNone/>
+            </a:pPr>
+            <a:r>
+              <a:rPr lang="en-US" sz="750" dirty="0">
+                <a:solidFill>
+                  <a:srgbClr val="6B7280"/>
+                </a:solidFill>
+                <a:latin typeface="Arial" pitchFamily="34" charset="0"/>
+                <a:ea typeface="Arial" pitchFamily="34" charset="-122"/>
+                <a:cs typeface="Arial" pitchFamily="34" charset="-120"/>
+              </a:rPr>
+              <a:t>14/09 – 25/09</a:t>
+            </a:r>
+            <a:endParaRPr lang="en-US" sz="750" dirty="0"/>
+          </a:p>
+        </p:txBody>
+      </p:sp>
+      <p:sp>
+        <p:nvSpPr>
+          <p:cNvPr id="38" name="Text 36"/>
+          <p:cNvSpPr txBox="1"/>
+          <p:nvPr/>
+        </p:nvSpPr>
+        <p:spPr>
+          <a:xfrm>
+            <a:off x="868680" y="2276856"/>
+            <a:ext cx="3017520" cy="246888"/>
+          </a:xfrm>
+          <a:prstGeom prst="rect">
+            <a:avLst/>
+          </a:prstGeom>
+          <a:noFill/>
+          <a:ln/>
+        </p:spPr>
+        <p:txBody>
+          <a:bodyPr wrap="square" lIns="0" tIns="0" rIns="0" bIns="0" rtlCol="0" anchor="ctr"/>
+          <a:lstStyle/>
+          <a:p>
+            <a:pPr indent="0" marL="0">
+              <a:buNone/>
+            </a:pPr>
+            <a:r>
+              <a:rPr lang="en-US" sz="900" dirty="0">
+                <a:solidFill>
+                  <a:srgbClr val="1F2937"/>
+                </a:solidFill>
+                <a:latin typeface="Arial" pitchFamily="34" charset="0"/>
+                <a:ea typeface="Arial" pitchFamily="34" charset="-122"/>
+                <a:cs typeface="Arial" pitchFamily="34" charset="-120"/>
+              </a:rPr>
+              <a:t>Priorizar problemas con Mantenimiento</a:t>
+            </a:r>
+            <a:endParaRPr lang="en-US" sz="900" dirty="0"/>
+          </a:p>
+        </p:txBody>
+      </p:sp>
+      <p:sp>
+        <p:nvSpPr>
+          <p:cNvPr id="39" name="Shape 37"/>
+          <p:cNvSpPr/>
+          <p:nvPr/>
+        </p:nvSpPr>
+        <p:spPr>
+          <a:xfrm>
+            <a:off x="4243178" y="2322576"/>
+            <a:ext cx="417274" cy="155448"/>
+          </a:xfrm>
+          <a:prstGeom prst="roundRect">
+            <a:avLst>
+              <a:gd name="adj" fmla="val 29412"/>
+            </a:avLst>
+          </a:prstGeom>
+          <a:solidFill>
+            <a:srgbClr val="022A5B">
+              <a:alpha val="55000"/>
+            </a:srgbClr>
+          </a:solidFill>
+          <a:ln w="9525">
+            <a:solidFill>
+              <a:srgbClr val="022A5B"/>
+            </a:solidFill>
+            <a:prstDash val="solid"/>
+          </a:ln>
+        </p:spPr>
+      </p:sp>
+      <p:sp>
+        <p:nvSpPr>
+          <p:cNvPr id="40" name="Text 38"/>
+          <p:cNvSpPr txBox="1"/>
+          <p:nvPr/>
+        </p:nvSpPr>
+        <p:spPr>
+          <a:xfrm>
+            <a:off x="3063240" y="2276856"/>
+            <a:ext cx="868680" cy="246888"/>
+          </a:xfrm>
+          <a:prstGeom prst="rect">
+            <a:avLst/>
+          </a:prstGeom>
+          <a:noFill/>
+          <a:ln/>
+        </p:spPr>
+        <p:txBody>
+          <a:bodyPr wrap="square" lIns="0" tIns="0" rIns="0" bIns="0" rtlCol="0" anchor="ctr"/>
+          <a:lstStyle/>
+          <a:p>
+            <a:pPr algn="r" indent="0" marL="0">
+              <a:buNone/>
+            </a:pPr>
+            <a:r>
+              <a:rPr lang="en-US" sz="750" dirty="0">
+                <a:solidFill>
+                  <a:srgbClr val="6B7280"/>
+                </a:solidFill>
+                <a:latin typeface="Arial" pitchFamily="34" charset="0"/>
+                <a:ea typeface="Arial" pitchFamily="34" charset="-122"/>
+                <a:cs typeface="Arial" pitchFamily="34" charset="-120"/>
+              </a:rPr>
+              <a:t>21/09 – 02/10</a:t>
+            </a:r>
+            <a:endParaRPr lang="en-US" sz="750" dirty="0"/>
+          </a:p>
+        </p:txBody>
+      </p:sp>
+      <p:sp>
+        <p:nvSpPr>
+          <p:cNvPr id="41" name="Text 39"/>
+          <p:cNvSpPr txBox="1"/>
+          <p:nvPr/>
+        </p:nvSpPr>
+        <p:spPr>
+          <a:xfrm>
+            <a:off x="868680" y="2523744"/>
+            <a:ext cx="3017520" cy="246888"/>
+          </a:xfrm>
+          <a:prstGeom prst="rect">
+            <a:avLst/>
+          </a:prstGeom>
+          <a:noFill/>
+          <a:ln/>
+        </p:spPr>
+        <p:txBody>
+          <a:bodyPr wrap="square" lIns="0" tIns="0" rIns="0" bIns="0" rtlCol="0" anchor="ctr"/>
+          <a:lstStyle/>
+          <a:p>
+            <a:pPr indent="0" marL="0">
+              <a:buNone/>
+            </a:pPr>
+            <a:r>
+              <a:rPr lang="en-US" sz="900" dirty="0">
+                <a:solidFill>
+                  <a:srgbClr val="1F2937"/>
+                </a:solidFill>
+                <a:latin typeface="Arial" pitchFamily="34" charset="0"/>
+                <a:ea typeface="Arial" pitchFamily="34" charset="-122"/>
+                <a:cs typeface="Arial" pitchFamily="34" charset="-120"/>
+              </a:rPr>
+              <a:t>Formar a los multiplicadores</a:t>
+            </a:r>
+            <a:endParaRPr lang="en-US" sz="900" dirty="0"/>
+          </a:p>
+        </p:txBody>
+      </p:sp>
+      <p:sp>
+        <p:nvSpPr>
+          <p:cNvPr id="42" name="Shape 40"/>
+          <p:cNvSpPr/>
+          <p:nvPr/>
+        </p:nvSpPr>
+        <p:spPr>
+          <a:xfrm>
+            <a:off x="4508716" y="2569464"/>
+            <a:ext cx="682812" cy="155448"/>
+          </a:xfrm>
+          <a:prstGeom prst="roundRect">
+            <a:avLst>
+              <a:gd name="adj" fmla="val 29412"/>
+            </a:avLst>
+          </a:prstGeom>
+          <a:solidFill>
+            <a:srgbClr val="022A5B">
+              <a:alpha val="55000"/>
+            </a:srgbClr>
+          </a:solidFill>
+          <a:ln w="9525">
+            <a:solidFill>
+              <a:srgbClr val="022A5B"/>
+            </a:solidFill>
+            <a:prstDash val="solid"/>
+          </a:ln>
+        </p:spPr>
+      </p:sp>
+      <p:sp>
+        <p:nvSpPr>
+          <p:cNvPr id="43" name="Text 41"/>
+          <p:cNvSpPr txBox="1"/>
+          <p:nvPr/>
+        </p:nvSpPr>
+        <p:spPr>
+          <a:xfrm>
+            <a:off x="3063240" y="2523744"/>
+            <a:ext cx="868680" cy="246888"/>
+          </a:xfrm>
+          <a:prstGeom prst="rect">
+            <a:avLst/>
+          </a:prstGeom>
+          <a:noFill/>
+          <a:ln/>
+        </p:spPr>
+        <p:txBody>
+          <a:bodyPr wrap="square" lIns="0" tIns="0" rIns="0" bIns="0" rtlCol="0" anchor="ctr"/>
+          <a:lstStyle/>
+          <a:p>
+            <a:pPr algn="r" indent="0" marL="0">
+              <a:buNone/>
+            </a:pPr>
+            <a:r>
+              <a:rPr lang="en-US" sz="750" dirty="0">
+                <a:solidFill>
+                  <a:srgbClr val="6B7280"/>
+                </a:solidFill>
+                <a:latin typeface="Arial" pitchFamily="34" charset="0"/>
+                <a:ea typeface="Arial" pitchFamily="34" charset="-122"/>
+                <a:cs typeface="Arial" pitchFamily="34" charset="-120"/>
+              </a:rPr>
+              <a:t>28/09 – 16/10</a:t>
+            </a:r>
+            <a:endParaRPr lang="en-US" sz="750" dirty="0"/>
+          </a:p>
+        </p:txBody>
+      </p:sp>
+      <p:sp>
+        <p:nvSpPr>
+          <p:cNvPr id="44" name="Shape 42"/>
+          <p:cNvSpPr/>
+          <p:nvPr/>
+        </p:nvSpPr>
+        <p:spPr>
+          <a:xfrm>
+            <a:off x="548640" y="2770632"/>
+            <a:ext cx="11091672" cy="246888"/>
+          </a:xfrm>
+          <a:prstGeom prst="rect">
+            <a:avLst/>
+          </a:prstGeom>
+          <a:solidFill>
+            <a:srgbClr val="F3F5F8"/>
+          </a:solidFill>
+          <a:ln w="12700">
+            <a:solidFill>
+              <a:srgbClr val="F3F5F8"/>
+            </a:solidFill>
+            <a:prstDash val="solid"/>
+          </a:ln>
+        </p:spPr>
+      </p:sp>
+      <p:sp>
+        <p:nvSpPr>
+          <p:cNvPr id="45" name="Text 43"/>
+          <p:cNvSpPr txBox="1"/>
+          <p:nvPr/>
+        </p:nvSpPr>
+        <p:spPr>
+          <a:xfrm>
+            <a:off x="640080" y="2770632"/>
+            <a:ext cx="3017520" cy="246888"/>
+          </a:xfrm>
+          <a:prstGeom prst="rect">
+            <a:avLst/>
+          </a:prstGeom>
+          <a:noFill/>
+          <a:ln/>
+        </p:spPr>
+        <p:txBody>
+          <a:bodyPr wrap="square" lIns="0" tIns="0" rIns="0" bIns="0" rtlCol="0" anchor="ctr"/>
+          <a:lstStyle/>
+          <a:p>
+            <a:pPr indent="0" marL="0">
+              <a:buNone/>
+            </a:pPr>
+            <a:r>
+              <a:rPr lang="en-US" sz="950" b="1" dirty="0">
+                <a:solidFill>
+                  <a:srgbClr val="022A5B"/>
+                </a:solidFill>
+                <a:latin typeface="Arial" pitchFamily="34" charset="0"/>
+                <a:ea typeface="Arial" pitchFamily="34" charset="-122"/>
+                <a:cs typeface="Arial" pitchFamily="34" charset="-120"/>
+              </a:rPr>
+              <a:t>FASE 2 · Construcción</a:t>
+            </a:r>
+            <a:endParaRPr lang="en-US" sz="950" dirty="0"/>
+          </a:p>
+        </p:txBody>
+      </p:sp>
+      <p:sp>
+        <p:nvSpPr>
+          <p:cNvPr id="46" name="Shape 44"/>
+          <p:cNvSpPr/>
+          <p:nvPr/>
+        </p:nvSpPr>
+        <p:spPr>
+          <a:xfrm>
+            <a:off x="5039793" y="2834640"/>
+            <a:ext cx="1479427" cy="118872"/>
+          </a:xfrm>
+          <a:prstGeom prst="rect">
+            <a:avLst/>
+          </a:prstGeom>
+          <a:solidFill>
+            <a:srgbClr val="0B3A73"/>
+          </a:solidFill>
+          <a:ln w="12700">
+            <a:solidFill>
+              <a:srgbClr val="0B3A73"/>
+            </a:solidFill>
+            <a:prstDash val="solid"/>
+          </a:ln>
+        </p:spPr>
+      </p:sp>
+      <p:sp>
+        <p:nvSpPr>
+          <p:cNvPr id="47" name="Text 45"/>
+          <p:cNvSpPr txBox="1"/>
+          <p:nvPr/>
+        </p:nvSpPr>
+        <p:spPr>
+          <a:xfrm>
+            <a:off x="3063240" y="2770632"/>
+            <a:ext cx="868680" cy="246888"/>
+          </a:xfrm>
+          <a:prstGeom prst="rect">
+            <a:avLst/>
+          </a:prstGeom>
+          <a:noFill/>
+          <a:ln/>
+        </p:spPr>
+        <p:txBody>
+          <a:bodyPr wrap="square" lIns="0" tIns="0" rIns="0" bIns="0" rtlCol="0" anchor="ctr"/>
+          <a:lstStyle/>
+          <a:p>
+            <a:pPr algn="r" indent="0" marL="0">
+              <a:buNone/>
+            </a:pPr>
+            <a:r>
+              <a:rPr lang="en-US" sz="750" dirty="0">
+                <a:solidFill>
+                  <a:srgbClr val="6B7280"/>
+                </a:solidFill>
+                <a:latin typeface="Arial" pitchFamily="34" charset="0"/>
+                <a:ea typeface="Arial" pitchFamily="34" charset="-122"/>
+                <a:cs typeface="Arial" pitchFamily="34" charset="-120"/>
+              </a:rPr>
+              <a:t>12/10 – 20/11</a:t>
+            </a:r>
+            <a:endParaRPr lang="en-US" sz="750" dirty="0"/>
+          </a:p>
+        </p:txBody>
+      </p:sp>
+      <p:sp>
+        <p:nvSpPr>
+          <p:cNvPr id="48" name="Text 46"/>
+          <p:cNvSpPr txBox="1"/>
+          <p:nvPr/>
+        </p:nvSpPr>
+        <p:spPr>
+          <a:xfrm>
+            <a:off x="868680" y="3017520"/>
+            <a:ext cx="3017520" cy="246888"/>
+          </a:xfrm>
+          <a:prstGeom prst="rect">
+            <a:avLst/>
+          </a:prstGeom>
+          <a:noFill/>
+          <a:ln/>
+        </p:spPr>
+        <p:txBody>
+          <a:bodyPr wrap="square" lIns="0" tIns="0" rIns="0" bIns="0" rtlCol="0" anchor="ctr"/>
+          <a:lstStyle/>
+          <a:p>
+            <a:pPr indent="0" marL="0">
+              <a:buNone/>
+            </a:pPr>
+            <a:r>
+              <a:rPr lang="en-US" sz="900" dirty="0">
+                <a:solidFill>
+                  <a:srgbClr val="1F2937"/>
+                </a:solidFill>
+                <a:latin typeface="Arial" pitchFamily="34" charset="0"/>
+                <a:ea typeface="Arial" pitchFamily="34" charset="-122"/>
+                <a:cs typeface="Arial" pitchFamily="34" charset="-120"/>
+              </a:rPr>
+              <a:t>Fabricar las 4 maquetas</a:t>
+            </a:r>
+            <a:endParaRPr lang="en-US" sz="900" dirty="0"/>
+          </a:p>
+        </p:txBody>
+      </p:sp>
+      <p:sp>
+        <p:nvSpPr>
+          <p:cNvPr id="49" name="Shape 47"/>
+          <p:cNvSpPr/>
+          <p:nvPr/>
+        </p:nvSpPr>
+        <p:spPr>
+          <a:xfrm>
+            <a:off x="5039793" y="3063240"/>
+            <a:ext cx="1213889" cy="155448"/>
+          </a:xfrm>
+          <a:prstGeom prst="roundRect">
+            <a:avLst>
+              <a:gd name="adj" fmla="val 29412"/>
+            </a:avLst>
+          </a:prstGeom>
+          <a:solidFill>
+            <a:srgbClr val="0B3A73">
+              <a:alpha val="55000"/>
+            </a:srgbClr>
+          </a:solidFill>
+          <a:ln w="9525">
+            <a:solidFill>
+              <a:srgbClr val="0B3A73"/>
+            </a:solidFill>
+            <a:prstDash val="solid"/>
+          </a:ln>
+        </p:spPr>
+      </p:sp>
+      <p:sp>
+        <p:nvSpPr>
+          <p:cNvPr id="50" name="Text 48"/>
+          <p:cNvSpPr txBox="1"/>
+          <p:nvPr/>
+        </p:nvSpPr>
+        <p:spPr>
+          <a:xfrm>
+            <a:off x="3063240" y="3017520"/>
+            <a:ext cx="868680" cy="246888"/>
+          </a:xfrm>
+          <a:prstGeom prst="rect">
+            <a:avLst/>
+          </a:prstGeom>
+          <a:noFill/>
+          <a:ln/>
+        </p:spPr>
+        <p:txBody>
+          <a:bodyPr wrap="square" lIns="0" tIns="0" rIns="0" bIns="0" rtlCol="0" anchor="ctr"/>
+          <a:lstStyle/>
+          <a:p>
+            <a:pPr algn="r" indent="0" marL="0">
+              <a:buNone/>
+            </a:pPr>
+            <a:r>
+              <a:rPr lang="en-US" sz="750" dirty="0">
+                <a:solidFill>
+                  <a:srgbClr val="6B7280"/>
+                </a:solidFill>
+                <a:latin typeface="Arial" pitchFamily="34" charset="0"/>
+                <a:ea typeface="Arial" pitchFamily="34" charset="-122"/>
+                <a:cs typeface="Arial" pitchFamily="34" charset="-120"/>
+              </a:rPr>
+              <a:t>12/10 – 13/11</a:t>
+            </a:r>
+            <a:endParaRPr lang="en-US" sz="750" dirty="0"/>
+          </a:p>
+        </p:txBody>
+      </p:sp>
+      <p:sp>
+        <p:nvSpPr>
+          <p:cNvPr id="51" name="Text 49"/>
+          <p:cNvSpPr txBox="1"/>
+          <p:nvPr/>
+        </p:nvSpPr>
+        <p:spPr>
+          <a:xfrm>
+            <a:off x="868680" y="3264408"/>
+            <a:ext cx="3017520" cy="246888"/>
+          </a:xfrm>
+          <a:prstGeom prst="rect">
+            <a:avLst/>
+          </a:prstGeom>
+          <a:noFill/>
+          <a:ln/>
+        </p:spPr>
+        <p:txBody>
+          <a:bodyPr wrap="square" lIns="0" tIns="0" rIns="0" bIns="0" rtlCol="0" anchor="ctr"/>
+          <a:lstStyle/>
+          <a:p>
+            <a:pPr indent="0" marL="0">
+              <a:buNone/>
+            </a:pPr>
+            <a:r>
+              <a:rPr lang="en-US" sz="900" dirty="0">
+                <a:solidFill>
+                  <a:srgbClr val="1F2937"/>
+                </a:solidFill>
+                <a:latin typeface="Arial" pitchFamily="34" charset="0"/>
+                <a:ea typeface="Arial" pitchFamily="34" charset="-122"/>
+                <a:cs typeface="Arial" pitchFamily="34" charset="-120"/>
+              </a:rPr>
+              <a:t>Imprimir tótems y señalización del sector</a:t>
+            </a:r>
+            <a:endParaRPr lang="en-US" sz="900" dirty="0"/>
+          </a:p>
+        </p:txBody>
+      </p:sp>
+      <p:sp>
+        <p:nvSpPr>
+          <p:cNvPr id="52" name="Shape 50"/>
+          <p:cNvSpPr/>
+          <p:nvPr/>
+        </p:nvSpPr>
+        <p:spPr>
+          <a:xfrm>
+            <a:off x="5039793" y="3310128"/>
+            <a:ext cx="682812" cy="155448"/>
+          </a:xfrm>
+          <a:prstGeom prst="roundRect">
+            <a:avLst>
+              <a:gd name="adj" fmla="val 29412"/>
+            </a:avLst>
+          </a:prstGeom>
+          <a:solidFill>
+            <a:srgbClr val="0B3A73">
+              <a:alpha val="55000"/>
+            </a:srgbClr>
+          </a:solidFill>
+          <a:ln w="9525">
+            <a:solidFill>
+              <a:srgbClr val="0B3A73"/>
+            </a:solidFill>
+            <a:prstDash val="solid"/>
+          </a:ln>
+        </p:spPr>
+      </p:sp>
+      <p:sp>
+        <p:nvSpPr>
+          <p:cNvPr id="53" name="Text 51"/>
+          <p:cNvSpPr txBox="1"/>
+          <p:nvPr/>
+        </p:nvSpPr>
+        <p:spPr>
+          <a:xfrm>
+            <a:off x="3063240" y="3264408"/>
+            <a:ext cx="868680" cy="246888"/>
+          </a:xfrm>
+          <a:prstGeom prst="rect">
+            <a:avLst/>
+          </a:prstGeom>
+          <a:noFill/>
+          <a:ln/>
+        </p:spPr>
+        <p:txBody>
+          <a:bodyPr wrap="square" lIns="0" tIns="0" rIns="0" bIns="0" rtlCol="0" anchor="ctr"/>
+          <a:lstStyle/>
+          <a:p>
+            <a:pPr algn="r" indent="0" marL="0">
+              <a:buNone/>
+            </a:pPr>
+            <a:r>
+              <a:rPr lang="en-US" sz="750" dirty="0">
+                <a:solidFill>
+                  <a:srgbClr val="6B7280"/>
+                </a:solidFill>
+                <a:latin typeface="Arial" pitchFamily="34" charset="0"/>
+                <a:ea typeface="Arial" pitchFamily="34" charset="-122"/>
+                <a:cs typeface="Arial" pitchFamily="34" charset="-120"/>
+              </a:rPr>
+              <a:t>12/10 – 30/10</a:t>
+            </a:r>
+            <a:endParaRPr lang="en-US" sz="750" dirty="0"/>
+          </a:p>
+        </p:txBody>
+      </p:sp>
+      <p:sp>
+        <p:nvSpPr>
+          <p:cNvPr id="54" name="Text 52"/>
+          <p:cNvSpPr txBox="1"/>
+          <p:nvPr/>
+        </p:nvSpPr>
+        <p:spPr>
+          <a:xfrm>
+            <a:off x="868680" y="3511296"/>
+            <a:ext cx="3017520" cy="246888"/>
+          </a:xfrm>
+          <a:prstGeom prst="rect">
+            <a:avLst/>
+          </a:prstGeom>
+          <a:noFill/>
+          <a:ln/>
+        </p:spPr>
+        <p:txBody>
+          <a:bodyPr wrap="square" lIns="0" tIns="0" rIns="0" bIns="0" rtlCol="0" anchor="ctr"/>
+          <a:lstStyle/>
+          <a:p>
+            <a:pPr indent="0" marL="0">
+              <a:buNone/>
+            </a:pPr>
+            <a:r>
+              <a:rPr lang="en-US" sz="900" dirty="0">
+                <a:solidFill>
+                  <a:srgbClr val="1F2937"/>
+                </a:solidFill>
+                <a:latin typeface="Arial" pitchFamily="34" charset="0"/>
+                <a:ea typeface="Arial" pitchFamily="34" charset="-122"/>
+                <a:cs typeface="Arial" pitchFamily="34" charset="-120"/>
+              </a:rPr>
+              <a:t>Crear contenido y estándares LLA</a:t>
+            </a:r>
+            <a:endParaRPr lang="en-US" sz="900" dirty="0"/>
+          </a:p>
+        </p:txBody>
+      </p:sp>
+      <p:sp>
+        <p:nvSpPr>
+          <p:cNvPr id="55" name="Shape 53"/>
+          <p:cNvSpPr/>
+          <p:nvPr/>
+        </p:nvSpPr>
+        <p:spPr>
+          <a:xfrm>
+            <a:off x="5305331" y="3557016"/>
+            <a:ext cx="948350" cy="155448"/>
+          </a:xfrm>
+          <a:prstGeom prst="roundRect">
+            <a:avLst>
+              <a:gd name="adj" fmla="val 29412"/>
+            </a:avLst>
+          </a:prstGeom>
+          <a:solidFill>
+            <a:srgbClr val="0B3A73">
+              <a:alpha val="55000"/>
+            </a:srgbClr>
+          </a:solidFill>
+          <a:ln w="9525">
+            <a:solidFill>
+              <a:srgbClr val="0B3A73"/>
+            </a:solidFill>
+            <a:prstDash val="solid"/>
+          </a:ln>
+        </p:spPr>
+      </p:sp>
+      <p:sp>
+        <p:nvSpPr>
+          <p:cNvPr id="56" name="Text 54"/>
+          <p:cNvSpPr txBox="1"/>
+          <p:nvPr/>
+        </p:nvSpPr>
+        <p:spPr>
+          <a:xfrm>
+            <a:off x="3063240" y="3511296"/>
+            <a:ext cx="868680" cy="246888"/>
+          </a:xfrm>
+          <a:prstGeom prst="rect">
+            <a:avLst/>
+          </a:prstGeom>
+          <a:noFill/>
+          <a:ln/>
+        </p:spPr>
+        <p:txBody>
+          <a:bodyPr wrap="square" lIns="0" tIns="0" rIns="0" bIns="0" rtlCol="0" anchor="ctr"/>
+          <a:lstStyle/>
+          <a:p>
+            <a:pPr algn="r" indent="0" marL="0">
+              <a:buNone/>
+            </a:pPr>
+            <a:r>
+              <a:rPr lang="en-US" sz="750" dirty="0">
+                <a:solidFill>
+                  <a:srgbClr val="6B7280"/>
+                </a:solidFill>
+                <a:latin typeface="Arial" pitchFamily="34" charset="0"/>
+                <a:ea typeface="Arial" pitchFamily="34" charset="-122"/>
+                <a:cs typeface="Arial" pitchFamily="34" charset="-120"/>
+              </a:rPr>
+              <a:t>19/10 – 13/11</a:t>
+            </a:r>
+            <a:endParaRPr lang="en-US" sz="750" dirty="0"/>
+          </a:p>
+        </p:txBody>
+      </p:sp>
+      <p:sp>
+        <p:nvSpPr>
+          <p:cNvPr id="57" name="Text 55"/>
+          <p:cNvSpPr txBox="1"/>
+          <p:nvPr/>
+        </p:nvSpPr>
+        <p:spPr>
+          <a:xfrm>
+            <a:off x="868680" y="3758184"/>
+            <a:ext cx="3017520" cy="246888"/>
+          </a:xfrm>
+          <a:prstGeom prst="rect">
+            <a:avLst/>
+          </a:prstGeom>
+          <a:noFill/>
+          <a:ln/>
+        </p:spPr>
+        <p:txBody>
+          <a:bodyPr wrap="square" lIns="0" tIns="0" rIns="0" bIns="0" rtlCol="0" anchor="ctr"/>
+          <a:lstStyle/>
+          <a:p>
+            <a:pPr indent="0" marL="0">
+              <a:buNone/>
+            </a:pPr>
+            <a:r>
+              <a:rPr lang="en-US" sz="900" dirty="0">
+                <a:solidFill>
+                  <a:srgbClr val="1F2937"/>
+                </a:solidFill>
+                <a:latin typeface="Arial" pitchFamily="34" charset="0"/>
+                <a:ea typeface="Arial" pitchFamily="34" charset="-122"/>
+                <a:cs typeface="Arial" pitchFamily="34" charset="-120"/>
+              </a:rPr>
+              <a:t>Adaptar el AM Game a Pintura</a:t>
+            </a:r>
+            <a:endParaRPr lang="en-US" sz="900" dirty="0"/>
+          </a:p>
+        </p:txBody>
+      </p:sp>
+      <p:sp>
+        <p:nvSpPr>
+          <p:cNvPr id="58" name="Shape 56"/>
+          <p:cNvSpPr/>
+          <p:nvPr/>
+        </p:nvSpPr>
+        <p:spPr>
+          <a:xfrm>
+            <a:off x="5570869" y="3803904"/>
+            <a:ext cx="948350" cy="155448"/>
+          </a:xfrm>
+          <a:prstGeom prst="roundRect">
+            <a:avLst>
+              <a:gd name="adj" fmla="val 29412"/>
+            </a:avLst>
+          </a:prstGeom>
+          <a:solidFill>
+            <a:srgbClr val="0B3A73">
+              <a:alpha val="55000"/>
+            </a:srgbClr>
+          </a:solidFill>
+          <a:ln w="9525">
+            <a:solidFill>
+              <a:srgbClr val="0B3A73"/>
+            </a:solidFill>
+            <a:prstDash val="solid"/>
+          </a:ln>
+        </p:spPr>
+      </p:sp>
+      <p:sp>
+        <p:nvSpPr>
+          <p:cNvPr id="59" name="Text 57"/>
+          <p:cNvSpPr txBox="1"/>
+          <p:nvPr/>
+        </p:nvSpPr>
+        <p:spPr>
+          <a:xfrm>
+            <a:off x="3063240" y="3758184"/>
+            <a:ext cx="868680" cy="246888"/>
+          </a:xfrm>
+          <a:prstGeom prst="rect">
+            <a:avLst/>
+          </a:prstGeom>
+          <a:noFill/>
+          <a:ln/>
+        </p:spPr>
+        <p:txBody>
+          <a:bodyPr wrap="square" lIns="0" tIns="0" rIns="0" bIns="0" rtlCol="0" anchor="ctr"/>
+          <a:lstStyle/>
+          <a:p>
+            <a:pPr algn="r" indent="0" marL="0">
+              <a:buNone/>
+            </a:pPr>
+            <a:r>
+              <a:rPr lang="en-US" sz="750" dirty="0">
+                <a:solidFill>
+                  <a:srgbClr val="6B7280"/>
+                </a:solidFill>
+                <a:latin typeface="Arial" pitchFamily="34" charset="0"/>
+                <a:ea typeface="Arial" pitchFamily="34" charset="-122"/>
+                <a:cs typeface="Arial" pitchFamily="34" charset="-120"/>
+              </a:rPr>
+              <a:t>26/10 – 20/11</a:t>
+            </a:r>
+            <a:endParaRPr lang="en-US" sz="750" dirty="0"/>
+          </a:p>
+        </p:txBody>
+      </p:sp>
+      <p:sp>
+        <p:nvSpPr>
+          <p:cNvPr id="60" name="Shape 58"/>
+          <p:cNvSpPr/>
+          <p:nvPr/>
+        </p:nvSpPr>
+        <p:spPr>
+          <a:xfrm>
+            <a:off x="548640" y="4005072"/>
+            <a:ext cx="11091672" cy="246888"/>
+          </a:xfrm>
+          <a:prstGeom prst="rect">
+            <a:avLst/>
+          </a:prstGeom>
+          <a:solidFill>
+            <a:srgbClr val="F3F5F8"/>
+          </a:solidFill>
+          <a:ln w="12700">
+            <a:solidFill>
+              <a:srgbClr val="F3F5F8"/>
+            </a:solidFill>
+            <a:prstDash val="solid"/>
+          </a:ln>
+        </p:spPr>
+      </p:sp>
+      <p:sp>
+        <p:nvSpPr>
+          <p:cNvPr id="61" name="Text 59"/>
+          <p:cNvSpPr txBox="1"/>
+          <p:nvPr/>
+        </p:nvSpPr>
+        <p:spPr>
+          <a:xfrm>
+            <a:off x="640080" y="4005072"/>
+            <a:ext cx="3017520" cy="246888"/>
+          </a:xfrm>
+          <a:prstGeom prst="rect">
+            <a:avLst/>
+          </a:prstGeom>
+          <a:noFill/>
+          <a:ln/>
+        </p:spPr>
+        <p:txBody>
+          <a:bodyPr wrap="square" lIns="0" tIns="0" rIns="0" bIns="0" rtlCol="0" anchor="ctr"/>
+          <a:lstStyle/>
+          <a:p>
+            <a:pPr indent="0" marL="0">
+              <a:buNone/>
+            </a:pPr>
+            <a:r>
+              <a:rPr lang="en-US" sz="950" b="1" dirty="0">
+                <a:solidFill>
+                  <a:srgbClr val="022A5B"/>
+                </a:solidFill>
+                <a:latin typeface="Arial" pitchFamily="34" charset="0"/>
+                <a:ea typeface="Arial" pitchFamily="34" charset="-122"/>
+                <a:cs typeface="Arial" pitchFamily="34" charset="-120"/>
+              </a:rPr>
+              <a:t>FASE 3 · Piloto</a:t>
+            </a:r>
+            <a:endParaRPr lang="en-US" sz="950" dirty="0"/>
+          </a:p>
+        </p:txBody>
+      </p:sp>
+      <p:sp>
+        <p:nvSpPr>
+          <p:cNvPr id="62" name="Shape 60"/>
+          <p:cNvSpPr/>
+          <p:nvPr/>
+        </p:nvSpPr>
+        <p:spPr>
+          <a:xfrm>
+            <a:off x="6633021" y="4069080"/>
+            <a:ext cx="948350" cy="118872"/>
+          </a:xfrm>
+          <a:prstGeom prst="rect">
+            <a:avLst/>
+          </a:prstGeom>
+          <a:solidFill>
+            <a:srgbClr val="079CCE"/>
+          </a:solidFill>
+          <a:ln w="12700">
+            <a:solidFill>
+              <a:srgbClr val="079CCE"/>
+            </a:solidFill>
+            <a:prstDash val="solid"/>
+          </a:ln>
+        </p:spPr>
+      </p:sp>
+      <p:sp>
+        <p:nvSpPr>
+          <p:cNvPr id="63" name="Text 61"/>
+          <p:cNvSpPr txBox="1"/>
+          <p:nvPr/>
+        </p:nvSpPr>
+        <p:spPr>
+          <a:xfrm>
+            <a:off x="3063240" y="4005072"/>
+            <a:ext cx="868680" cy="246888"/>
+          </a:xfrm>
+          <a:prstGeom prst="rect">
+            <a:avLst/>
+          </a:prstGeom>
+          <a:noFill/>
+          <a:ln/>
+        </p:spPr>
+        <p:txBody>
+          <a:bodyPr wrap="square" lIns="0" tIns="0" rIns="0" bIns="0" rtlCol="0" anchor="ctr"/>
+          <a:lstStyle/>
+          <a:p>
+            <a:pPr algn="r" indent="0" marL="0">
+              <a:buNone/>
+            </a:pPr>
+            <a:r>
+              <a:rPr lang="en-US" sz="750" dirty="0">
+                <a:solidFill>
+                  <a:srgbClr val="6B7280"/>
+                </a:solidFill>
+                <a:latin typeface="Arial" pitchFamily="34" charset="0"/>
+                <a:ea typeface="Arial" pitchFamily="34" charset="-122"/>
+                <a:cs typeface="Arial" pitchFamily="34" charset="-120"/>
+              </a:rPr>
+              <a:t>23/11 – 18/12</a:t>
+            </a:r>
+            <a:endParaRPr lang="en-US" sz="750" dirty="0"/>
+          </a:p>
+        </p:txBody>
+      </p:sp>
+      <p:sp>
+        <p:nvSpPr>
+          <p:cNvPr id="64" name="Text 62"/>
+          <p:cNvSpPr txBox="1"/>
+          <p:nvPr/>
+        </p:nvSpPr>
+        <p:spPr>
+          <a:xfrm>
+            <a:off x="868680" y="4251960"/>
+            <a:ext cx="3017520" cy="246888"/>
+          </a:xfrm>
+          <a:prstGeom prst="rect">
+            <a:avLst/>
+          </a:prstGeom>
+          <a:noFill/>
+          <a:ln/>
+        </p:spPr>
+        <p:txBody>
+          <a:bodyPr wrap="square" lIns="0" tIns="0" rIns="0" bIns="0" rtlCol="0" anchor="ctr"/>
+          <a:lstStyle/>
+          <a:p>
+            <a:pPr indent="0" marL="0">
+              <a:buNone/>
+            </a:pPr>
+            <a:r>
+              <a:rPr lang="en-US" sz="900" dirty="0">
+                <a:solidFill>
+                  <a:srgbClr val="1F2937"/>
+                </a:solidFill>
+                <a:latin typeface="Arial" pitchFamily="34" charset="0"/>
+                <a:ea typeface="Arial" pitchFamily="34" charset="-122"/>
+                <a:cs typeface="Arial" pitchFamily="34" charset="-120"/>
+              </a:rPr>
+              <a:t>Sesiones piloto con el primer grupo</a:t>
+            </a:r>
+            <a:endParaRPr lang="en-US" sz="900" dirty="0"/>
+          </a:p>
+        </p:txBody>
+      </p:sp>
+      <p:sp>
+        <p:nvSpPr>
+          <p:cNvPr id="65" name="Shape 63"/>
+          <p:cNvSpPr/>
+          <p:nvPr/>
+        </p:nvSpPr>
+        <p:spPr>
+          <a:xfrm>
+            <a:off x="6633021" y="4297680"/>
+            <a:ext cx="417274" cy="155448"/>
+          </a:xfrm>
+          <a:prstGeom prst="roundRect">
+            <a:avLst>
+              <a:gd name="adj" fmla="val 29412"/>
+            </a:avLst>
+          </a:prstGeom>
+          <a:solidFill>
+            <a:srgbClr val="079CCE">
+              <a:alpha val="55000"/>
+            </a:srgbClr>
+          </a:solidFill>
+          <a:ln w="9525">
+            <a:solidFill>
+              <a:srgbClr val="079CCE"/>
+            </a:solidFill>
+            <a:prstDash val="solid"/>
+          </a:ln>
+        </p:spPr>
+      </p:sp>
+      <p:sp>
+        <p:nvSpPr>
+          <p:cNvPr id="66" name="Text 64"/>
+          <p:cNvSpPr txBox="1"/>
+          <p:nvPr/>
+        </p:nvSpPr>
+        <p:spPr>
+          <a:xfrm>
+            <a:off x="3063240" y="4251960"/>
+            <a:ext cx="868680" cy="246888"/>
+          </a:xfrm>
+          <a:prstGeom prst="rect">
+            <a:avLst/>
+          </a:prstGeom>
+          <a:noFill/>
+          <a:ln/>
+        </p:spPr>
+        <p:txBody>
+          <a:bodyPr wrap="square" lIns="0" tIns="0" rIns="0" bIns="0" rtlCol="0" anchor="ctr"/>
+          <a:lstStyle/>
+          <a:p>
+            <a:pPr algn="r" indent="0" marL="0">
+              <a:buNone/>
+            </a:pPr>
+            <a:r>
+              <a:rPr lang="en-US" sz="750" dirty="0">
+                <a:solidFill>
+                  <a:srgbClr val="6B7280"/>
+                </a:solidFill>
+                <a:latin typeface="Arial" pitchFamily="34" charset="0"/>
+                <a:ea typeface="Arial" pitchFamily="34" charset="-122"/>
+                <a:cs typeface="Arial" pitchFamily="34" charset="-120"/>
+              </a:rPr>
+              <a:t>23/11 – 04/12</a:t>
+            </a:r>
+            <a:endParaRPr lang="en-US" sz="750" dirty="0"/>
+          </a:p>
+        </p:txBody>
+      </p:sp>
+      <p:sp>
+        <p:nvSpPr>
+          <p:cNvPr id="67" name="Text 65"/>
+          <p:cNvSpPr txBox="1"/>
+          <p:nvPr/>
+        </p:nvSpPr>
+        <p:spPr>
+          <a:xfrm>
+            <a:off x="868680" y="4498848"/>
+            <a:ext cx="3017520" cy="246888"/>
+          </a:xfrm>
+          <a:prstGeom prst="rect">
+            <a:avLst/>
+          </a:prstGeom>
+          <a:noFill/>
+          <a:ln/>
+        </p:spPr>
+        <p:txBody>
+          <a:bodyPr wrap="square" lIns="0" tIns="0" rIns="0" bIns="0" rtlCol="0" anchor="ctr"/>
+          <a:lstStyle/>
+          <a:p>
+            <a:pPr indent="0" marL="0">
+              <a:buNone/>
+            </a:pPr>
+            <a:r>
+              <a:rPr lang="en-US" sz="900" dirty="0">
+                <a:solidFill>
+                  <a:srgbClr val="1F2937"/>
+                </a:solidFill>
+                <a:latin typeface="Arial" pitchFamily="34" charset="0"/>
+                <a:ea typeface="Arial" pitchFamily="34" charset="-122"/>
+                <a:cs typeface="Arial" pitchFamily="34" charset="-120"/>
+              </a:rPr>
+              <a:t>Ajustar tiempos y dificultad de los juegos</a:t>
+            </a:r>
+            <a:endParaRPr lang="en-US" sz="900" dirty="0"/>
+          </a:p>
+        </p:txBody>
+      </p:sp>
+      <p:sp>
+        <p:nvSpPr>
+          <p:cNvPr id="68" name="Shape 66"/>
+          <p:cNvSpPr/>
+          <p:nvPr/>
+        </p:nvSpPr>
+        <p:spPr>
+          <a:xfrm>
+            <a:off x="6898560" y="4544568"/>
+            <a:ext cx="417274" cy="155448"/>
+          </a:xfrm>
+          <a:prstGeom prst="roundRect">
+            <a:avLst>
+              <a:gd name="adj" fmla="val 29412"/>
+            </a:avLst>
+          </a:prstGeom>
+          <a:solidFill>
+            <a:srgbClr val="079CCE">
+              <a:alpha val="55000"/>
+            </a:srgbClr>
+          </a:solidFill>
+          <a:ln w="9525">
+            <a:solidFill>
+              <a:srgbClr val="079CCE"/>
+            </a:solidFill>
+            <a:prstDash val="solid"/>
+          </a:ln>
+        </p:spPr>
+      </p:sp>
+      <p:sp>
+        <p:nvSpPr>
+          <p:cNvPr id="69" name="Text 67"/>
+          <p:cNvSpPr txBox="1"/>
+          <p:nvPr/>
+        </p:nvSpPr>
+        <p:spPr>
+          <a:xfrm>
+            <a:off x="3063240" y="4498848"/>
+            <a:ext cx="868680" cy="246888"/>
+          </a:xfrm>
+          <a:prstGeom prst="rect">
+            <a:avLst/>
+          </a:prstGeom>
+          <a:noFill/>
+          <a:ln/>
+        </p:spPr>
+        <p:txBody>
+          <a:bodyPr wrap="square" lIns="0" tIns="0" rIns="0" bIns="0" rtlCol="0" anchor="ctr"/>
+          <a:lstStyle/>
+          <a:p>
+            <a:pPr algn="r" indent="0" marL="0">
+              <a:buNone/>
+            </a:pPr>
+            <a:r>
+              <a:rPr lang="en-US" sz="750" dirty="0">
+                <a:solidFill>
+                  <a:srgbClr val="6B7280"/>
+                </a:solidFill>
+                <a:latin typeface="Arial" pitchFamily="34" charset="0"/>
+                <a:ea typeface="Arial" pitchFamily="34" charset="-122"/>
+                <a:cs typeface="Arial" pitchFamily="34" charset="-120"/>
+              </a:rPr>
+              <a:t>30/11 – 11/12</a:t>
+            </a:r>
+            <a:endParaRPr lang="en-US" sz="750" dirty="0"/>
+          </a:p>
+        </p:txBody>
+      </p:sp>
+      <p:sp>
+        <p:nvSpPr>
+          <p:cNvPr id="70" name="Text 68"/>
+          <p:cNvSpPr txBox="1"/>
+          <p:nvPr/>
+        </p:nvSpPr>
+        <p:spPr>
+          <a:xfrm>
+            <a:off x="868680" y="4745736"/>
+            <a:ext cx="3017520" cy="246888"/>
+          </a:xfrm>
+          <a:prstGeom prst="rect">
+            <a:avLst/>
+          </a:prstGeom>
+          <a:noFill/>
+          <a:ln/>
+        </p:spPr>
+        <p:txBody>
+          <a:bodyPr wrap="square" lIns="0" tIns="0" rIns="0" bIns="0" rtlCol="0" anchor="ctr"/>
+          <a:lstStyle/>
+          <a:p>
+            <a:pPr indent="0" marL="0">
+              <a:buNone/>
+            </a:pPr>
+            <a:r>
+              <a:rPr lang="en-US" sz="900" dirty="0">
+                <a:solidFill>
+                  <a:srgbClr val="1F2937"/>
+                </a:solidFill>
+                <a:latin typeface="Arial" pitchFamily="34" charset="0"/>
+                <a:ea typeface="Arial" pitchFamily="34" charset="-122"/>
+                <a:cs typeface="Arial" pitchFamily="34" charset="-120"/>
+              </a:rPr>
+              <a:t>Medir resultados iniciales (línea base)</a:t>
+            </a:r>
+            <a:endParaRPr lang="en-US" sz="900" dirty="0"/>
+          </a:p>
+        </p:txBody>
+      </p:sp>
+      <p:sp>
+        <p:nvSpPr>
+          <p:cNvPr id="71" name="Shape 69"/>
+          <p:cNvSpPr/>
+          <p:nvPr/>
+        </p:nvSpPr>
+        <p:spPr>
+          <a:xfrm>
+            <a:off x="7164098" y="4791456"/>
+            <a:ext cx="417274" cy="155448"/>
+          </a:xfrm>
+          <a:prstGeom prst="roundRect">
+            <a:avLst>
+              <a:gd name="adj" fmla="val 29412"/>
+            </a:avLst>
+          </a:prstGeom>
+          <a:solidFill>
+            <a:srgbClr val="079CCE">
+              <a:alpha val="55000"/>
+            </a:srgbClr>
+          </a:solidFill>
+          <a:ln w="9525">
+            <a:solidFill>
+              <a:srgbClr val="079CCE"/>
+            </a:solidFill>
+            <a:prstDash val="solid"/>
+          </a:ln>
+        </p:spPr>
+      </p:sp>
+      <p:sp>
+        <p:nvSpPr>
+          <p:cNvPr id="72" name="Text 70"/>
+          <p:cNvSpPr txBox="1"/>
+          <p:nvPr/>
+        </p:nvSpPr>
+        <p:spPr>
+          <a:xfrm>
+            <a:off x="3063240" y="4745736"/>
+            <a:ext cx="868680" cy="246888"/>
+          </a:xfrm>
+          <a:prstGeom prst="rect">
+            <a:avLst/>
+          </a:prstGeom>
+          <a:noFill/>
+          <a:ln/>
+        </p:spPr>
+        <p:txBody>
+          <a:bodyPr wrap="square" lIns="0" tIns="0" rIns="0" bIns="0" rtlCol="0" anchor="ctr"/>
+          <a:lstStyle/>
+          <a:p>
+            <a:pPr algn="r" indent="0" marL="0">
+              <a:buNone/>
+            </a:pPr>
+            <a:r>
+              <a:rPr lang="en-US" sz="750" dirty="0">
+                <a:solidFill>
+                  <a:srgbClr val="6B7280"/>
+                </a:solidFill>
+                <a:latin typeface="Arial" pitchFamily="34" charset="0"/>
+                <a:ea typeface="Arial" pitchFamily="34" charset="-122"/>
+                <a:cs typeface="Arial" pitchFamily="34" charset="-120"/>
+              </a:rPr>
+              <a:t>07/12 – 18/12</a:t>
+            </a:r>
+            <a:endParaRPr lang="en-US" sz="750" dirty="0"/>
+          </a:p>
+        </p:txBody>
+      </p:sp>
+      <p:sp>
+        <p:nvSpPr>
+          <p:cNvPr id="73" name="Shape 71"/>
+          <p:cNvSpPr/>
+          <p:nvPr/>
+        </p:nvSpPr>
+        <p:spPr>
+          <a:xfrm>
+            <a:off x="548640" y="4992624"/>
+            <a:ext cx="11091672" cy="246888"/>
+          </a:xfrm>
+          <a:prstGeom prst="rect">
+            <a:avLst/>
+          </a:prstGeom>
+          <a:solidFill>
+            <a:srgbClr val="F3F5F8"/>
+          </a:solidFill>
+          <a:ln w="12700">
+            <a:solidFill>
+              <a:srgbClr val="F3F5F8"/>
+            </a:solidFill>
+            <a:prstDash val="solid"/>
+          </a:ln>
+        </p:spPr>
+      </p:sp>
+      <p:sp>
+        <p:nvSpPr>
+          <p:cNvPr id="74" name="Text 72"/>
+          <p:cNvSpPr txBox="1"/>
+          <p:nvPr/>
+        </p:nvSpPr>
+        <p:spPr>
+          <a:xfrm>
+            <a:off x="640080" y="4992624"/>
+            <a:ext cx="3017520" cy="246888"/>
+          </a:xfrm>
+          <a:prstGeom prst="rect">
+            <a:avLst/>
+          </a:prstGeom>
+          <a:noFill/>
+          <a:ln/>
+        </p:spPr>
+        <p:txBody>
+          <a:bodyPr wrap="square" lIns="0" tIns="0" rIns="0" bIns="0" rtlCol="0" anchor="ctr"/>
+          <a:lstStyle/>
+          <a:p>
+            <a:pPr indent="0" marL="0">
+              <a:buNone/>
+            </a:pPr>
+            <a:r>
+              <a:rPr lang="en-US" sz="950" b="1" dirty="0">
+                <a:solidFill>
+                  <a:srgbClr val="022A5B"/>
+                </a:solidFill>
+                <a:latin typeface="Arial" pitchFamily="34" charset="0"/>
+                <a:ea typeface="Arial" pitchFamily="34" charset="-122"/>
+                <a:cs typeface="Arial" pitchFamily="34" charset="-120"/>
+              </a:rPr>
+              <a:t>FASE 4 · Despliegue</a:t>
+            </a:r>
+            <a:endParaRPr lang="en-US" sz="950" dirty="0"/>
+          </a:p>
+        </p:txBody>
+      </p:sp>
+      <p:sp>
+        <p:nvSpPr>
+          <p:cNvPr id="75" name="Shape 73"/>
+          <p:cNvSpPr/>
+          <p:nvPr/>
+        </p:nvSpPr>
+        <p:spPr>
+          <a:xfrm>
+            <a:off x="8491788" y="5056632"/>
+            <a:ext cx="3072656" cy="118872"/>
+          </a:xfrm>
+          <a:prstGeom prst="rect">
+            <a:avLst/>
+          </a:prstGeom>
+          <a:solidFill>
+            <a:srgbClr val="FFA403"/>
+          </a:solidFill>
+          <a:ln w="12700">
+            <a:solidFill>
+              <a:srgbClr val="FFA403"/>
+            </a:solidFill>
+            <a:prstDash val="solid"/>
+          </a:ln>
+        </p:spPr>
+      </p:sp>
+      <p:sp>
+        <p:nvSpPr>
+          <p:cNvPr id="76" name="Text 74"/>
+          <p:cNvSpPr txBox="1"/>
+          <p:nvPr/>
+        </p:nvSpPr>
+        <p:spPr>
+          <a:xfrm>
+            <a:off x="3063240" y="4992624"/>
+            <a:ext cx="868680" cy="246888"/>
+          </a:xfrm>
+          <a:prstGeom prst="rect">
+            <a:avLst/>
+          </a:prstGeom>
+          <a:noFill/>
+          <a:ln/>
+        </p:spPr>
+        <p:txBody>
+          <a:bodyPr wrap="square" lIns="0" tIns="0" rIns="0" bIns="0" rtlCol="0" anchor="ctr"/>
+          <a:lstStyle/>
+          <a:p>
+            <a:pPr algn="r" indent="0" marL="0">
+              <a:buNone/>
+            </a:pPr>
+            <a:r>
+              <a:rPr lang="en-US" sz="750" dirty="0">
+                <a:solidFill>
+                  <a:srgbClr val="6B7280"/>
+                </a:solidFill>
+                <a:latin typeface="Arial" pitchFamily="34" charset="0"/>
+                <a:ea typeface="Arial" pitchFamily="34" charset="-122"/>
+                <a:cs typeface="Arial" pitchFamily="34" charset="-120"/>
+              </a:rPr>
+              <a:t>11/01 – 02/04</a:t>
+            </a:r>
+            <a:endParaRPr lang="en-US" sz="750" dirty="0"/>
+          </a:p>
+        </p:txBody>
+      </p:sp>
+      <p:sp>
+        <p:nvSpPr>
+          <p:cNvPr id="77" name="Text 75"/>
+          <p:cNvSpPr txBox="1"/>
+          <p:nvPr/>
+        </p:nvSpPr>
+        <p:spPr>
+          <a:xfrm>
+            <a:off x="868680" y="5239512"/>
+            <a:ext cx="3017520" cy="246888"/>
+          </a:xfrm>
+          <a:prstGeom prst="rect">
+            <a:avLst/>
+          </a:prstGeom>
+          <a:noFill/>
+          <a:ln/>
+        </p:spPr>
+        <p:txBody>
+          <a:bodyPr wrap="square" lIns="0" tIns="0" rIns="0" bIns="0" rtlCol="0" anchor="ctr"/>
+          <a:lstStyle/>
+          <a:p>
+            <a:pPr indent="0" marL="0">
+              <a:buNone/>
+            </a:pPr>
+            <a:r>
+              <a:rPr lang="en-US" sz="900" dirty="0">
+                <a:solidFill>
+                  <a:srgbClr val="1F2937"/>
+                </a:solidFill>
+                <a:latin typeface="Arial" pitchFamily="34" charset="0"/>
+                <a:ea typeface="Arial" pitchFamily="34" charset="-122"/>
+                <a:cs typeface="Arial" pitchFamily="34" charset="-120"/>
+              </a:rPr>
+              <a:t>Sesiones para todos los turnos y líneas</a:t>
+            </a:r>
+            <a:endParaRPr lang="en-US" sz="900" dirty="0"/>
+          </a:p>
+        </p:txBody>
+      </p:sp>
+      <p:sp>
+        <p:nvSpPr>
+          <p:cNvPr id="78" name="Shape 76"/>
+          <p:cNvSpPr/>
+          <p:nvPr/>
+        </p:nvSpPr>
+        <p:spPr>
+          <a:xfrm>
+            <a:off x="8491788" y="5285232"/>
+            <a:ext cx="2807117" cy="155448"/>
+          </a:xfrm>
+          <a:prstGeom prst="roundRect">
+            <a:avLst>
+              <a:gd name="adj" fmla="val 29412"/>
+            </a:avLst>
+          </a:prstGeom>
+          <a:solidFill>
+            <a:srgbClr val="FFA403">
+              <a:alpha val="55000"/>
+            </a:srgbClr>
+          </a:solidFill>
+          <a:ln w="9525">
+            <a:solidFill>
+              <a:srgbClr val="FFA403"/>
+            </a:solidFill>
+            <a:prstDash val="solid"/>
+          </a:ln>
+        </p:spPr>
+      </p:sp>
+      <p:sp>
+        <p:nvSpPr>
+          <p:cNvPr id="79" name="Text 77"/>
+          <p:cNvSpPr txBox="1"/>
+          <p:nvPr/>
+        </p:nvSpPr>
+        <p:spPr>
+          <a:xfrm>
+            <a:off x="3063240" y="5239512"/>
+            <a:ext cx="868680" cy="246888"/>
+          </a:xfrm>
+          <a:prstGeom prst="rect">
+            <a:avLst/>
+          </a:prstGeom>
+          <a:noFill/>
+          <a:ln/>
+        </p:spPr>
+        <p:txBody>
+          <a:bodyPr wrap="square" lIns="0" tIns="0" rIns="0" bIns="0" rtlCol="0" anchor="ctr"/>
+          <a:lstStyle/>
+          <a:p>
+            <a:pPr algn="r" indent="0" marL="0">
+              <a:buNone/>
+            </a:pPr>
+            <a:r>
+              <a:rPr lang="en-US" sz="750" dirty="0">
+                <a:solidFill>
+                  <a:srgbClr val="6B7280"/>
+                </a:solidFill>
+                <a:latin typeface="Arial" pitchFamily="34" charset="0"/>
+                <a:ea typeface="Arial" pitchFamily="34" charset="-122"/>
+                <a:cs typeface="Arial" pitchFamily="34" charset="-120"/>
+              </a:rPr>
+              <a:t>11/01 – 26/03</a:t>
+            </a:r>
+            <a:endParaRPr lang="en-US" sz="750" dirty="0"/>
+          </a:p>
+        </p:txBody>
+      </p:sp>
+      <p:sp>
+        <p:nvSpPr>
+          <p:cNvPr id="80" name="Text 78"/>
+          <p:cNvSpPr txBox="1"/>
+          <p:nvPr/>
+        </p:nvSpPr>
+        <p:spPr>
+          <a:xfrm>
+            <a:off x="868680" y="5486400"/>
+            <a:ext cx="3017520" cy="246888"/>
+          </a:xfrm>
+          <a:prstGeom prst="rect">
+            <a:avLst/>
+          </a:prstGeom>
+          <a:noFill/>
+          <a:ln/>
+        </p:spPr>
+        <p:txBody>
+          <a:bodyPr wrap="square" lIns="0" tIns="0" rIns="0" bIns="0" rtlCol="0" anchor="ctr"/>
+          <a:lstStyle/>
+          <a:p>
+            <a:pPr indent="0" marL="0">
+              <a:buNone/>
+            </a:pPr>
+            <a:r>
+              <a:rPr lang="en-US" sz="900" dirty="0">
+                <a:solidFill>
+                  <a:srgbClr val="1F2937"/>
+                </a:solidFill>
+                <a:latin typeface="Arial" pitchFamily="34" charset="0"/>
+                <a:ea typeface="Arial" pitchFamily="34" charset="-122"/>
+                <a:cs typeface="Arial" pitchFamily="34" charset="-120"/>
+              </a:rPr>
+              <a:t>Ranking y reconocimiento</a:t>
+            </a:r>
+            <a:endParaRPr lang="en-US" sz="900" dirty="0"/>
+          </a:p>
+        </p:txBody>
+      </p:sp>
+      <p:sp>
+        <p:nvSpPr>
+          <p:cNvPr id="81" name="Shape 79"/>
+          <p:cNvSpPr/>
+          <p:nvPr/>
+        </p:nvSpPr>
+        <p:spPr>
+          <a:xfrm>
+            <a:off x="9022865" y="5532120"/>
+            <a:ext cx="2541579" cy="155448"/>
+          </a:xfrm>
+          <a:prstGeom prst="roundRect">
+            <a:avLst>
+              <a:gd name="adj" fmla="val 29412"/>
+            </a:avLst>
+          </a:prstGeom>
+          <a:solidFill>
+            <a:srgbClr val="FFA403">
+              <a:alpha val="55000"/>
+            </a:srgbClr>
+          </a:solidFill>
+          <a:ln w="9525">
+            <a:solidFill>
+              <a:srgbClr val="FFA403"/>
+            </a:solidFill>
+            <a:prstDash val="solid"/>
+          </a:ln>
+        </p:spPr>
+      </p:sp>
+      <p:sp>
+        <p:nvSpPr>
+          <p:cNvPr id="82" name="Text 80"/>
+          <p:cNvSpPr txBox="1"/>
+          <p:nvPr/>
+        </p:nvSpPr>
+        <p:spPr>
+          <a:xfrm>
+            <a:off x="3063240" y="5486400"/>
+            <a:ext cx="868680" cy="246888"/>
+          </a:xfrm>
+          <a:prstGeom prst="rect">
+            <a:avLst/>
+          </a:prstGeom>
+          <a:noFill/>
+          <a:ln/>
+        </p:spPr>
+        <p:txBody>
+          <a:bodyPr wrap="square" lIns="0" tIns="0" rIns="0" bIns="0" rtlCol="0" anchor="ctr"/>
+          <a:lstStyle/>
+          <a:p>
+            <a:pPr algn="r" indent="0" marL="0">
+              <a:buNone/>
+            </a:pPr>
+            <a:r>
+              <a:rPr lang="en-US" sz="750" dirty="0">
+                <a:solidFill>
+                  <a:srgbClr val="6B7280"/>
+                </a:solidFill>
+                <a:latin typeface="Arial" pitchFamily="34" charset="0"/>
+                <a:ea typeface="Arial" pitchFamily="34" charset="-122"/>
+                <a:cs typeface="Arial" pitchFamily="34" charset="-120"/>
+              </a:rPr>
+              <a:t>25/01 – 02/04</a:t>
+            </a:r>
+            <a:endParaRPr lang="en-US" sz="750" dirty="0"/>
+          </a:p>
+        </p:txBody>
+      </p:sp>
+      <p:sp>
+        <p:nvSpPr>
+          <p:cNvPr id="83" name="Text 81"/>
+          <p:cNvSpPr txBox="1"/>
+          <p:nvPr/>
+        </p:nvSpPr>
+        <p:spPr>
+          <a:xfrm>
+            <a:off x="868680" y="5733288"/>
+            <a:ext cx="3017520" cy="246888"/>
+          </a:xfrm>
+          <a:prstGeom prst="rect">
+            <a:avLst/>
+          </a:prstGeom>
+          <a:noFill/>
+          <a:ln/>
+        </p:spPr>
+        <p:txBody>
+          <a:bodyPr wrap="square" lIns="0" tIns="0" rIns="0" bIns="0" rtlCol="0" anchor="ctr"/>
+          <a:lstStyle/>
+          <a:p>
+            <a:pPr indent="0" marL="0">
+              <a:buNone/>
+            </a:pPr>
+            <a:r>
+              <a:rPr lang="en-US" sz="900" dirty="0">
+                <a:solidFill>
+                  <a:srgbClr val="1F2937"/>
+                </a:solidFill>
+                <a:latin typeface="Arial" pitchFamily="34" charset="0"/>
+                <a:ea typeface="Arial" pitchFamily="34" charset="-122"/>
+                <a:cs typeface="Arial" pitchFamily="34" charset="-120"/>
+              </a:rPr>
+              <a:t>Seguimiento mensual de indicadores</a:t>
+            </a:r>
+            <a:endParaRPr lang="en-US" sz="900" dirty="0"/>
+          </a:p>
+        </p:txBody>
+      </p:sp>
+      <p:sp>
+        <p:nvSpPr>
+          <p:cNvPr id="84" name="Shape 82"/>
+          <p:cNvSpPr/>
+          <p:nvPr/>
+        </p:nvSpPr>
+        <p:spPr>
+          <a:xfrm>
+            <a:off x="9288403" y="5779008"/>
+            <a:ext cx="2276041" cy="155448"/>
+          </a:xfrm>
+          <a:prstGeom prst="roundRect">
+            <a:avLst>
+              <a:gd name="adj" fmla="val 29412"/>
+            </a:avLst>
+          </a:prstGeom>
+          <a:solidFill>
+            <a:srgbClr val="FFA403">
+              <a:alpha val="55000"/>
+            </a:srgbClr>
+          </a:solidFill>
+          <a:ln w="9525">
+            <a:solidFill>
+              <a:srgbClr val="FFA403"/>
+            </a:solidFill>
+            <a:prstDash val="solid"/>
+          </a:ln>
+        </p:spPr>
+      </p:sp>
+      <p:sp>
+        <p:nvSpPr>
+          <p:cNvPr id="85" name="Text 83"/>
+          <p:cNvSpPr txBox="1"/>
+          <p:nvPr/>
+        </p:nvSpPr>
+        <p:spPr>
+          <a:xfrm>
+            <a:off x="3063240" y="5733288"/>
+            <a:ext cx="868680" cy="246888"/>
+          </a:xfrm>
+          <a:prstGeom prst="rect">
+            <a:avLst/>
+          </a:prstGeom>
+          <a:noFill/>
+          <a:ln/>
+        </p:spPr>
+        <p:txBody>
+          <a:bodyPr wrap="square" lIns="0" tIns="0" rIns="0" bIns="0" rtlCol="0" anchor="ctr"/>
+          <a:lstStyle/>
+          <a:p>
+            <a:pPr algn="r" indent="0" marL="0">
+              <a:buNone/>
+            </a:pPr>
+            <a:r>
+              <a:rPr lang="en-US" sz="750" dirty="0">
+                <a:solidFill>
+                  <a:srgbClr val="6B7280"/>
+                </a:solidFill>
+                <a:latin typeface="Arial" pitchFamily="34" charset="0"/>
+                <a:ea typeface="Arial" pitchFamily="34" charset="-122"/>
+                <a:cs typeface="Arial" pitchFamily="34" charset="-120"/>
+              </a:rPr>
+              <a:t>01/02 – 02/04</a:t>
+            </a:r>
+            <a:endParaRPr lang="en-US" sz="750" dirty="0"/>
+          </a:p>
+        </p:txBody>
+      </p:sp>
+      <p:sp>
+        <p:nvSpPr>
+          <p:cNvPr id="86" name="Shape 84"/>
+          <p:cNvSpPr/>
+          <p:nvPr/>
+        </p:nvSpPr>
+        <p:spPr>
+          <a:xfrm>
+            <a:off x="4825406" y="1805940"/>
+            <a:ext cx="201168" cy="201168"/>
+          </a:xfrm>
+          <a:prstGeom prst="diamond">
+            <a:avLst/>
+          </a:prstGeom>
+          <a:solidFill>
+            <a:srgbClr val="E42312"/>
+          </a:solidFill>
+          <a:ln w="12700">
+            <a:solidFill>
+              <a:srgbClr val="FFFFFF"/>
+            </a:solidFill>
+            <a:prstDash val="solid"/>
+          </a:ln>
+        </p:spPr>
+      </p:sp>
+      <p:sp>
+        <p:nvSpPr>
+          <p:cNvPr id="87" name="Shape 85"/>
+          <p:cNvSpPr/>
+          <p:nvPr/>
+        </p:nvSpPr>
+        <p:spPr>
+          <a:xfrm>
+            <a:off x="6418635" y="2793492"/>
+            <a:ext cx="201168" cy="201168"/>
+          </a:xfrm>
+          <a:prstGeom prst="diamond">
+            <a:avLst/>
+          </a:prstGeom>
+          <a:solidFill>
+            <a:srgbClr val="E42312"/>
+          </a:solidFill>
+          <a:ln w="12700">
+            <a:solidFill>
+              <a:srgbClr val="FFFFFF"/>
+            </a:solidFill>
+            <a:prstDash val="solid"/>
+          </a:ln>
+        </p:spPr>
+      </p:sp>
+      <p:sp>
+        <p:nvSpPr>
+          <p:cNvPr id="88" name="Shape 86"/>
+          <p:cNvSpPr/>
+          <p:nvPr/>
+        </p:nvSpPr>
+        <p:spPr>
+          <a:xfrm>
+            <a:off x="7480788" y="4027932"/>
+            <a:ext cx="201168" cy="201168"/>
+          </a:xfrm>
+          <a:prstGeom prst="diamond">
+            <a:avLst/>
+          </a:prstGeom>
+          <a:solidFill>
+            <a:srgbClr val="E42312"/>
+          </a:solidFill>
+          <a:ln w="12700">
+            <a:solidFill>
+              <a:srgbClr val="FFFFFF"/>
+            </a:solidFill>
+            <a:prstDash val="solid"/>
+          </a:ln>
+        </p:spPr>
+      </p:sp>
+      <p:sp>
+        <p:nvSpPr>
+          <p:cNvPr id="89" name="Shape 87"/>
+          <p:cNvSpPr/>
+          <p:nvPr/>
+        </p:nvSpPr>
+        <p:spPr>
+          <a:xfrm>
+            <a:off x="11463860" y="5015484"/>
+            <a:ext cx="201168" cy="201168"/>
+          </a:xfrm>
+          <a:prstGeom prst="diamond">
+            <a:avLst/>
+          </a:prstGeom>
+          <a:solidFill>
+            <a:srgbClr val="E42312"/>
+          </a:solidFill>
+          <a:ln w="12700">
+            <a:solidFill>
+              <a:srgbClr val="FFFFFF"/>
+            </a:solidFill>
+            <a:prstDash val="solid"/>
+          </a:ln>
+        </p:spPr>
+      </p:sp>
+      <p:sp>
+        <p:nvSpPr>
+          <p:cNvPr id="90" name="Shape 88"/>
+          <p:cNvSpPr/>
+          <p:nvPr/>
+        </p:nvSpPr>
+        <p:spPr>
+          <a:xfrm>
+            <a:off x="640080" y="6309360"/>
+            <a:ext cx="164592" cy="164592"/>
+          </a:xfrm>
+          <a:prstGeom prst="diamond">
+            <a:avLst/>
+          </a:prstGeom>
+          <a:solidFill>
+            <a:srgbClr val="E42312"/>
+          </a:solidFill>
+          <a:ln w="12700">
+            <a:solidFill>
+              <a:srgbClr val="FFFFFF"/>
+            </a:solidFill>
+            <a:prstDash val="solid"/>
+          </a:ln>
+        </p:spPr>
+      </p:sp>
+      <p:sp>
+        <p:nvSpPr>
+          <p:cNvPr id="91" name="Text 89"/>
+          <p:cNvSpPr txBox="1"/>
+          <p:nvPr/>
+        </p:nvSpPr>
+        <p:spPr>
+          <a:xfrm>
+            <a:off x="914400" y="6272784"/>
+            <a:ext cx="10698480" cy="237744"/>
+          </a:xfrm>
+          <a:prstGeom prst="rect">
+            <a:avLst/>
+          </a:prstGeom>
+          <a:noFill/>
+          <a:ln/>
+        </p:spPr>
+        <p:txBody>
+          <a:bodyPr wrap="square" lIns="0" tIns="0" rIns="0" bIns="0" rtlCol="0" anchor="ctr"/>
+          <a:lstStyle/>
+          <a:p>
+            <a:pPr indent="0" marL="0">
+              <a:buNone/>
+            </a:pPr>
+            <a:r>
+              <a:rPr lang="en-US" sz="900" dirty="0">
+                <a:solidFill>
+                  <a:srgbClr val="1F2937"/>
+                </a:solidFill>
+                <a:latin typeface="Arial" pitchFamily="34" charset="0"/>
+                <a:ea typeface="Arial" pitchFamily="34" charset="-122"/>
+                <a:cs typeface="Arial" pitchFamily="34" charset="-120"/>
+              </a:rPr>
+              <a:t>Hitos: 09/10 layout y presupuesto aprobados · 20/11 maquetas y tótems listos · 18/12 go/no-go del despliegue · 02/04 100% de los turnos certificados</a:t>
+            </a:r>
+            <a:endParaRPr lang="en-US" sz="900" dirty="0"/>
+          </a:p>
+        </p:txBody>
+      </p:sp>
+      <p:sp>
+        <p:nvSpPr>
+          <p:cNvPr id="92" name="Text 90"/>
+          <p:cNvSpPr txBox="1"/>
+          <p:nvPr/>
+        </p:nvSpPr>
+        <p:spPr>
+          <a:xfrm>
+            <a:off x="640080" y="6547104"/>
+            <a:ext cx="10972800" cy="237744"/>
+          </a:xfrm>
+          <a:prstGeom prst="rect">
+            <a:avLst/>
+          </a:prstGeom>
+          <a:noFill/>
+          <a:ln/>
+        </p:spPr>
+        <p:txBody>
+          <a:bodyPr wrap="square" lIns="0" tIns="0" rIns="0" bIns="0" rtlCol="0" anchor="ctr"/>
+          <a:lstStyle/>
+          <a:p>
+            <a:pPr indent="0" marL="0">
+              <a:buNone/>
+            </a:pPr>
+            <a:r>
+              <a:rPr lang="en-US" sz="900" i="1" dirty="0">
+                <a:solidFill>
+                  <a:srgbClr val="6B7280"/>
+                </a:solidFill>
+                <a:latin typeface="Arial" pitchFamily="34" charset="0"/>
+                <a:ea typeface="Arial" pitchFamily="34" charset="-122"/>
+                <a:cs typeface="Arial" pitchFamily="34" charset="-120"/>
+              </a:rPr>
+              <a:t>Duración total: 29 semanas (14/09/2026 a 02/04/2027), con receso de fin de año del 21/12 al 08/01. Fechas propuestas: se ajustan con la fecha real de aprobación.</a:t>
+            </a:r>
+            <a:endParaRPr lang="en-US" sz="900" dirty="0"/>
+          </a:p>
+        </p:txBody>
+      </p:sp>
+      <p:sp>
+        <p:nvSpPr>
+          <p:cNvPr id="93" name="Text 91"/>
+          <p:cNvSpPr txBox="1"/>
+          <p:nvPr/>
+        </p:nvSpPr>
+        <p:spPr>
+          <a:xfrm>
+            <a:off x="11155680" y="6355080"/>
+            <a:ext cx="484632" cy="274320"/>
+          </a:xfrm>
+          <a:prstGeom prst="rect">
+            <a:avLst/>
+          </a:prstGeom>
+          <a:noFill/>
+          <a:ln/>
+        </p:spPr>
+        <p:txBody>
+          <a:bodyPr wrap="square" lIns="0" tIns="0" rIns="0" bIns="0" rtlCol="0" anchor="ctr"/>
+          <a:lstStyle/>
+          <a:p>
+            <a:pPr algn="r" indent="0" marL="0">
+              <a:buNone/>
+            </a:pPr>
+            <a:r>
+              <a:rPr lang="en-US" sz="1000" dirty="0">
+                <a:solidFill>
+                  <a:srgbClr val="6B7280"/>
+                </a:solidFill>
+                <a:latin typeface="Arial" pitchFamily="34" charset="0"/>
+                <a:ea typeface="Arial" pitchFamily="34" charset="-122"/>
+                <a:cs typeface="Arial" pitchFamily="34" charset="-120"/>
+              </a:rPr>
+              <a:t>13</a:t>
+            </a:r>
+            <a:endParaRPr lang="en-US" sz="1000" dirty="0"/>
+          </a:p>
+        </p:txBody>
+      </p:sp>
+    </p:spTree>
+  </p:cSld>
+  <p:clrMapOvr>
+    <a:masterClrMapping/>
+  </p:clrMapOvr>
+</p:sld>
+</file>
+
+<file path=ppt/slides/slide14.xml><?xml version="1.0" encoding="utf-8"?>
+<p:sld xmlns:a="http://schemas.openxmlformats.org/drawingml/2006/main" xmlns:r="http://schemas.openxmlformats.org/officeDocument/2006/relationships" xmlns:p="http://schemas.openxmlformats.org/presentationml/2006/main">
+  <p:cSld name="Slide 14">
+    <p:bg>
+      <p:bgPr>
+        <a:solidFill>
           <a:srgbClr val="F3F5F8"/>
         </a:solidFill>
       </p:bgPr>
@@ -6573,7 +9716,7 @@
                 <a:ea typeface="Arial" pitchFamily="34" charset="-122"/>
                 <a:cs typeface="Arial" pitchFamily="34" charset="-120"/>
               </a:rPr>
-              <a:t>13</a:t>
+              <a:t>14</a:t>
             </a:r>
             <a:endParaRPr lang="en-US" sz="1000" dirty="0"/>
           </a:p>
@@ -6587,9 +9730,9 @@
 </p:sld>
 </file>
 
-<file path=ppt/slides/slide14.xml><?xml version="1.0" encoding="utf-8"?>
+<file path=ppt/slides/slide15.xml><?xml version="1.0" encoding="utf-8"?>
 <p:sld xmlns:a="http://schemas.openxmlformats.org/drawingml/2006/main" xmlns:r="http://schemas.openxmlformats.org/officeDocument/2006/relationships" xmlns:p="http://schemas.openxmlformats.org/presentationml/2006/main">
-  <p:cSld name="Slide 14">
+  <p:cSld name="Slide 15">
     <p:bg>
       <p:bgPr>
         <a:blipFill dpi="0" rotWithShape="1">

</xml_diff>

<commit_message>
Comprimir el cronograma del Dojo AM para cerrar el 23/12/2026
Fases solapadas en 15 semanas: diseño, construcción, piloto de dos
semanas y despliegue a todos los turnos antes del receso.

Co-Authored-By: Claude Fable 5.1 <noreply@anthropic.com>
Claude-Session: https://claude.ai/code/session_013R5zM6jAzpk9971GWdT5eG
</commit_message>
<xml_diff>
--- a/docs/Dojo_AM_Unidad_Pintura.pptx
+++ b/docs/Dojo_AM_Unidad_Pintura.pptx
@@ -868,7 +868,7 @@
           <a:p>
             <a:r>
               <a:rPr lang="en-US" dirty="0"/>
-              <a:t>Cronograma propuesto de 29 semanas: diseño en septiembre, construcción de octubre a noviembre, piloto en diciembre y despliegue de enero a abril de 2027. Los hitos marcan las decisiones clave: aprobación del layout y presupuesto, maquetas listas, go/no-go y cierre del despliegue.</a:t>
+              <a:t>Cronograma comprimido de 15 semanas para cerrar antes del receso: diseño en septiembre, construcción de fines de septiembre a inicios de noviembre, piloto de dos semanas en noviembre y despliegue a todos los turnos entre el 23 de noviembre y el 23 de diciembre. Riesgo principal: el plazo de fabricación de las maquetas, que debe arrancar con el layout todavía en cierre.</a:t>
             </a:r>
             <a:endParaRPr lang="en-US" dirty="0"/>
           </a:p>
@@ -5579,7 +5579,7 @@
                 <a:ea typeface="Arial" pitchFamily="34" charset="-122"/>
                 <a:cs typeface="Arial" pitchFamily="34" charset="-120"/>
               </a:rPr>
-              <a:t>Cronograma: de la aprobación al despliegue</a:t>
+              <a:t>Cronograma: todo listo para fines de diciembre</a:t>
             </a:r>
             <a:endParaRPr lang="en-US" sz="2800" dirty="0"/>
           </a:p>
@@ -5632,72 +5632,8 @@
         </p:nvSpPr>
         <p:spPr>
           <a:xfrm>
-            <a:off x="7695174" y="1783080"/>
-            <a:ext cx="682812" cy="4197096"/>
-          </a:xfrm>
-          <a:prstGeom prst="rect">
-            <a:avLst/>
-          </a:prstGeom>
-          <a:solidFill>
-            <a:srgbClr val="D9E0EA"/>
-          </a:solidFill>
-          <a:ln w="12700">
-            <a:solidFill>
-              <a:srgbClr val="D9E0EA"/>
-            </a:solidFill>
-            <a:prstDash val="solid"/>
-          </a:ln>
-        </p:spPr>
-      </p:sp>
-      <p:sp>
-        <p:nvSpPr>
-          <p:cNvPr id="5" name="Text 3"/>
-          <p:cNvSpPr txBox="1"/>
-          <p:nvPr/>
-        </p:nvSpPr>
-        <p:spPr>
-          <a:xfrm>
-            <a:off x="7512294" y="5998464"/>
-            <a:ext cx="1048572" cy="201168"/>
-          </a:xfrm>
-          <a:prstGeom prst="rect">
-            <a:avLst/>
-          </a:prstGeom>
-          <a:noFill/>
-          <a:ln/>
-        </p:spPr>
-        <p:txBody>
-          <a:bodyPr wrap="square" lIns="0" tIns="0" rIns="0" bIns="0" rtlCol="0" anchor="ctr"/>
-          <a:lstStyle/>
-          <a:p>
-            <a:pPr algn="ctr" indent="0" marL="0">
-              <a:buNone/>
-            </a:pPr>
-            <a:r>
-              <a:rPr lang="en-US" sz="800" dirty="0">
-                <a:solidFill>
-                  <a:srgbClr val="6B7280"/>
-                </a:solidFill>
-                <a:latin typeface="Arial" pitchFamily="34" charset="0"/>
-                <a:ea typeface="Arial" pitchFamily="34" charset="-122"/>
-                <a:cs typeface="Arial" pitchFamily="34" charset="-120"/>
-              </a:rPr>
-              <a:t>Receso</a:t>
-            </a:r>
-            <a:endParaRPr lang="en-US" sz="800" dirty="0"/>
-          </a:p>
-        </p:txBody>
-      </p:sp>
-      <p:sp>
-        <p:nvSpPr>
-          <p:cNvPr id="6" name="Shape 4"/>
-          <p:cNvSpPr/>
-          <p:nvPr/>
-        </p:nvSpPr>
-        <p:spPr>
-          <a:xfrm>
             <a:off x="3977640" y="1399032"/>
-            <a:ext cx="644878" cy="329184"/>
+            <a:ext cx="1252552" cy="329184"/>
           </a:xfrm>
           <a:prstGeom prst="rect">
             <a:avLst/>
@@ -5715,14 +5651,14 @@
       </p:sp>
       <p:sp>
         <p:nvSpPr>
-          <p:cNvPr id="7" name="Text 5"/>
+          <p:cNvPr id="5" name="Text 3"/>
           <p:cNvSpPr txBox="1"/>
           <p:nvPr/>
         </p:nvSpPr>
         <p:spPr>
           <a:xfrm>
             <a:off x="3977640" y="1399032"/>
-            <a:ext cx="644878" cy="329184"/>
+            <a:ext cx="1252552" cy="329184"/>
           </a:xfrm>
           <a:prstGeom prst="rect">
             <a:avLst/>
@@ -5746,7 +5682,7 @@
                 <a:ea typeface="Arial" pitchFamily="34" charset="-122"/>
                 <a:cs typeface="Arial" pitchFamily="34" charset="-120"/>
               </a:rPr>
-              <a:t>Sep</a:t>
+              <a:t>Septiembre</a:t>
             </a:r>
             <a:endParaRPr lang="en-US" sz="1000" dirty="0"/>
           </a:p>
@@ -5754,7 +5690,7 @@
       </p:sp>
       <p:sp>
         <p:nvSpPr>
-          <p:cNvPr id="8" name="Shape 6"/>
+          <p:cNvPr id="6" name="Shape 4"/>
           <p:cNvSpPr/>
           <p:nvPr/>
         </p:nvSpPr>
@@ -5777,14 +5713,14 @@
       </p:sp>
       <p:sp>
         <p:nvSpPr>
-          <p:cNvPr id="9" name="Shape 7"/>
+          <p:cNvPr id="7" name="Shape 5"/>
           <p:cNvSpPr/>
           <p:nvPr/>
         </p:nvSpPr>
         <p:spPr>
           <a:xfrm>
-            <a:off x="4622518" y="1399032"/>
-            <a:ext cx="1175955" cy="329184"/>
+            <a:off x="5230192" y="1399032"/>
+            <a:ext cx="2284066" cy="329184"/>
           </a:xfrm>
           <a:prstGeom prst="rect">
             <a:avLst/>
@@ -5802,14 +5738,14 @@
       </p:sp>
       <p:sp>
         <p:nvSpPr>
-          <p:cNvPr id="10" name="Text 8"/>
-          <p:cNvSpPr txBox="1"/>
-          <p:nvPr/>
-        </p:nvSpPr>
-        <p:spPr>
-          <a:xfrm>
-            <a:off x="4622518" y="1399032"/>
-            <a:ext cx="1175955" cy="329184"/>
+          <p:cNvPr id="8" name="Text 6"/>
+          <p:cNvSpPr txBox="1"/>
+          <p:nvPr/>
+        </p:nvSpPr>
+        <p:spPr>
+          <a:xfrm>
+            <a:off x="5230192" y="1399032"/>
+            <a:ext cx="2284066" cy="329184"/>
           </a:xfrm>
           <a:prstGeom prst="rect">
             <a:avLst/>
@@ -5833,7 +5769,7 @@
                 <a:ea typeface="Arial" pitchFamily="34" charset="-122"/>
                 <a:cs typeface="Arial" pitchFamily="34" charset="-120"/>
               </a:rPr>
-              <a:t>Oct</a:t>
+              <a:t>Octubre</a:t>
             </a:r>
             <a:endParaRPr lang="en-US" sz="1000" dirty="0"/>
           </a:p>
@@ -5841,13 +5777,13 @@
       </p:sp>
       <p:sp>
         <p:nvSpPr>
-          <p:cNvPr id="11" name="Shape 9"/>
+          <p:cNvPr id="9" name="Shape 7"/>
           <p:cNvSpPr/>
           <p:nvPr/>
         </p:nvSpPr>
         <p:spPr>
           <a:xfrm>
-            <a:off x="4622518" y="1783080"/>
+            <a:off x="5230192" y="1783080"/>
             <a:ext cx="0" cy="4197096"/>
           </a:xfrm>
           <a:prstGeom prst="line">
@@ -5864,14 +5800,14 @@
       </p:sp>
       <p:sp>
         <p:nvSpPr>
-          <p:cNvPr id="12" name="Shape 10"/>
+          <p:cNvPr id="10" name="Shape 8"/>
           <p:cNvSpPr/>
           <p:nvPr/>
         </p:nvSpPr>
         <p:spPr>
           <a:xfrm>
-            <a:off x="5798473" y="1399032"/>
-            <a:ext cx="1138021" cy="329184"/>
+            <a:off x="7514258" y="1399032"/>
+            <a:ext cx="2210386" cy="329184"/>
           </a:xfrm>
           <a:prstGeom prst="rect">
             <a:avLst/>
@@ -5889,14 +5825,14 @@
       </p:sp>
       <p:sp>
         <p:nvSpPr>
-          <p:cNvPr id="13" name="Text 11"/>
-          <p:cNvSpPr txBox="1"/>
-          <p:nvPr/>
-        </p:nvSpPr>
-        <p:spPr>
-          <a:xfrm>
-            <a:off x="5798473" y="1399032"/>
-            <a:ext cx="1138021" cy="329184"/>
+          <p:cNvPr id="11" name="Text 9"/>
+          <p:cNvSpPr txBox="1"/>
+          <p:nvPr/>
+        </p:nvSpPr>
+        <p:spPr>
+          <a:xfrm>
+            <a:off x="7514258" y="1399032"/>
+            <a:ext cx="2210386" cy="329184"/>
           </a:xfrm>
           <a:prstGeom prst="rect">
             <a:avLst/>
@@ -5920,7 +5856,7 @@
                 <a:ea typeface="Arial" pitchFamily="34" charset="-122"/>
                 <a:cs typeface="Arial" pitchFamily="34" charset="-120"/>
               </a:rPr>
-              <a:t>Nov</a:t>
+              <a:t>Noviembre</a:t>
             </a:r>
             <a:endParaRPr lang="en-US" sz="1000" dirty="0"/>
           </a:p>
@@ -5928,13 +5864,13 @@
       </p:sp>
       <p:sp>
         <p:nvSpPr>
-          <p:cNvPr id="14" name="Shape 12"/>
+          <p:cNvPr id="12" name="Shape 10"/>
           <p:cNvSpPr/>
           <p:nvPr/>
         </p:nvSpPr>
         <p:spPr>
           <a:xfrm>
-            <a:off x="5798473" y="1783080"/>
+            <a:off x="7514258" y="1783080"/>
             <a:ext cx="0" cy="4197096"/>
           </a:xfrm>
           <a:prstGeom prst="line">
@@ -5951,14 +5887,14 @@
       </p:sp>
       <p:sp>
         <p:nvSpPr>
-          <p:cNvPr id="15" name="Shape 13"/>
+          <p:cNvPr id="13" name="Shape 11"/>
           <p:cNvSpPr/>
           <p:nvPr/>
         </p:nvSpPr>
         <p:spPr>
           <a:xfrm>
-            <a:off x="6936494" y="1399032"/>
-            <a:ext cx="1175955" cy="329184"/>
+            <a:off x="9724644" y="1399032"/>
+            <a:ext cx="1915668" cy="329184"/>
           </a:xfrm>
           <a:prstGeom prst="rect">
             <a:avLst/>
@@ -5976,14 +5912,14 @@
       </p:sp>
       <p:sp>
         <p:nvSpPr>
-          <p:cNvPr id="16" name="Text 14"/>
-          <p:cNvSpPr txBox="1"/>
-          <p:nvPr/>
-        </p:nvSpPr>
-        <p:spPr>
-          <a:xfrm>
-            <a:off x="6936494" y="1399032"/>
-            <a:ext cx="1175955" cy="329184"/>
+          <p:cNvPr id="14" name="Text 12"/>
+          <p:cNvSpPr txBox="1"/>
+          <p:nvPr/>
+        </p:nvSpPr>
+        <p:spPr>
+          <a:xfrm>
+            <a:off x="9724644" y="1399032"/>
+            <a:ext cx="1915668" cy="329184"/>
           </a:xfrm>
           <a:prstGeom prst="rect">
             <a:avLst/>
@@ -6007,7 +5943,7 @@
                 <a:ea typeface="Arial" pitchFamily="34" charset="-122"/>
                 <a:cs typeface="Arial" pitchFamily="34" charset="-120"/>
               </a:rPr>
-              <a:t>Dic</a:t>
+              <a:t>Diciembre</a:t>
             </a:r>
             <a:endParaRPr lang="en-US" sz="1000" dirty="0"/>
           </a:p>
@@ -6015,13 +5951,13 @@
       </p:sp>
       <p:sp>
         <p:nvSpPr>
-          <p:cNvPr id="17" name="Shape 15"/>
+          <p:cNvPr id="15" name="Shape 13"/>
           <p:cNvSpPr/>
           <p:nvPr/>
         </p:nvSpPr>
         <p:spPr>
           <a:xfrm>
-            <a:off x="6936494" y="1783080"/>
+            <a:off x="9724644" y="1783080"/>
             <a:ext cx="0" cy="4197096"/>
           </a:xfrm>
           <a:prstGeom prst="line">
@@ -6038,24 +5974,22 @@
       </p:sp>
       <p:sp>
         <p:nvSpPr>
-          <p:cNvPr id="18" name="Shape 16"/>
+          <p:cNvPr id="16" name="Shape 14"/>
           <p:cNvSpPr/>
           <p:nvPr/>
         </p:nvSpPr>
         <p:spPr>
           <a:xfrm>
-            <a:off x="8112448" y="1399032"/>
-            <a:ext cx="1175955" cy="329184"/>
-          </a:xfrm>
-          <a:prstGeom prst="rect">
-            <a:avLst/>
-          </a:prstGeom>
-          <a:solidFill>
-            <a:srgbClr val="F3F5F8"/>
-          </a:solidFill>
-          <a:ln w="12700">
+            <a:off x="3977640" y="1783080"/>
+            <a:ext cx="0" cy="4197096"/>
+          </a:xfrm>
+          <a:prstGeom prst="line">
+            <a:avLst/>
+          </a:prstGeom>
+          <a:noFill/>
+          <a:ln w="6350">
             <a:solidFill>
-              <a:srgbClr val="FFFFFF"/>
+              <a:srgbClr val="EEF1F5"/>
             </a:solidFill>
             <a:prstDash val="solid"/>
           </a:ln>
@@ -6063,61 +5997,22 @@
       </p:sp>
       <p:sp>
         <p:nvSpPr>
-          <p:cNvPr id="19" name="Text 17"/>
-          <p:cNvSpPr txBox="1"/>
-          <p:nvPr/>
-        </p:nvSpPr>
-        <p:spPr>
-          <a:xfrm>
-            <a:off x="8112448" y="1399032"/>
-            <a:ext cx="1175955" cy="329184"/>
-          </a:xfrm>
-          <a:prstGeom prst="rect">
-            <a:avLst/>
-          </a:prstGeom>
-          <a:noFill/>
-          <a:ln/>
-        </p:spPr>
-        <p:txBody>
-          <a:bodyPr wrap="square" lIns="0" tIns="0" rIns="0" bIns="0" rtlCol="0" anchor="ctr"/>
-          <a:lstStyle/>
-          <a:p>
-            <a:pPr algn="ctr" indent="0" marL="0">
-              <a:buNone/>
-            </a:pPr>
-            <a:r>
-              <a:rPr lang="en-US" sz="1000" b="1" dirty="0">
-                <a:solidFill>
-                  <a:srgbClr val="022A5B"/>
-                </a:solidFill>
-                <a:latin typeface="Arial" pitchFamily="34" charset="0"/>
-                <a:ea typeface="Arial" pitchFamily="34" charset="-122"/>
-                <a:cs typeface="Arial" pitchFamily="34" charset="-120"/>
-              </a:rPr>
-              <a:t>Ene 2027</a:t>
-            </a:r>
-            <a:endParaRPr lang="en-US" sz="1000" dirty="0"/>
-          </a:p>
-        </p:txBody>
-      </p:sp>
-      <p:sp>
-        <p:nvSpPr>
-          <p:cNvPr id="20" name="Shape 18"/>
+          <p:cNvPr id="17" name="Shape 15"/>
           <p:cNvSpPr/>
           <p:nvPr/>
         </p:nvSpPr>
         <p:spPr>
           <a:xfrm>
-            <a:off x="8112448" y="1783080"/>
+            <a:off x="4493397" y="1783080"/>
             <a:ext cx="0" cy="4197096"/>
           </a:xfrm>
           <a:prstGeom prst="line">
             <a:avLst/>
           </a:prstGeom>
           <a:noFill/>
-          <a:ln w="9525">
+          <a:ln w="6350">
             <a:solidFill>
-              <a:srgbClr val="D9E0EA"/>
+              <a:srgbClr val="EEF1F5"/>
             </a:solidFill>
             <a:prstDash val="solid"/>
           </a:ln>
@@ -6125,24 +6020,22 @@
       </p:sp>
       <p:sp>
         <p:nvSpPr>
-          <p:cNvPr id="21" name="Shape 19"/>
+          <p:cNvPr id="18" name="Shape 16"/>
           <p:cNvSpPr/>
           <p:nvPr/>
         </p:nvSpPr>
         <p:spPr>
           <a:xfrm>
-            <a:off x="9288403" y="1399032"/>
-            <a:ext cx="1062153" cy="329184"/>
-          </a:xfrm>
-          <a:prstGeom prst="rect">
-            <a:avLst/>
-          </a:prstGeom>
-          <a:solidFill>
-            <a:srgbClr val="F3F5F8"/>
-          </a:solidFill>
-          <a:ln w="12700">
+            <a:off x="5009154" y="1783080"/>
+            <a:ext cx="0" cy="4197096"/>
+          </a:xfrm>
+          <a:prstGeom prst="line">
+            <a:avLst/>
+          </a:prstGeom>
+          <a:noFill/>
+          <a:ln w="6350">
             <a:solidFill>
-              <a:srgbClr val="FFFFFF"/>
+              <a:srgbClr val="EEF1F5"/>
             </a:solidFill>
             <a:prstDash val="solid"/>
           </a:ln>
@@ -6150,61 +6043,22 @@
       </p:sp>
       <p:sp>
         <p:nvSpPr>
-          <p:cNvPr id="22" name="Text 20"/>
-          <p:cNvSpPr txBox="1"/>
-          <p:nvPr/>
-        </p:nvSpPr>
-        <p:spPr>
-          <a:xfrm>
-            <a:off x="9288403" y="1399032"/>
-            <a:ext cx="1062153" cy="329184"/>
-          </a:xfrm>
-          <a:prstGeom prst="rect">
-            <a:avLst/>
-          </a:prstGeom>
-          <a:noFill/>
-          <a:ln/>
-        </p:spPr>
-        <p:txBody>
-          <a:bodyPr wrap="square" lIns="0" tIns="0" rIns="0" bIns="0" rtlCol="0" anchor="ctr"/>
-          <a:lstStyle/>
-          <a:p>
-            <a:pPr algn="ctr" indent="0" marL="0">
-              <a:buNone/>
-            </a:pPr>
-            <a:r>
-              <a:rPr lang="en-US" sz="1000" b="1" dirty="0">
-                <a:solidFill>
-                  <a:srgbClr val="022A5B"/>
-                </a:solidFill>
-                <a:latin typeface="Arial" pitchFamily="34" charset="0"/>
-                <a:ea typeface="Arial" pitchFamily="34" charset="-122"/>
-                <a:cs typeface="Arial" pitchFamily="34" charset="-120"/>
-              </a:rPr>
-              <a:t>Feb</a:t>
-            </a:r>
-            <a:endParaRPr lang="en-US" sz="1000" dirty="0"/>
-          </a:p>
-        </p:txBody>
-      </p:sp>
-      <p:sp>
-        <p:nvSpPr>
-          <p:cNvPr id="23" name="Shape 21"/>
+          <p:cNvPr id="19" name="Shape 17"/>
           <p:cNvSpPr/>
           <p:nvPr/>
         </p:nvSpPr>
         <p:spPr>
           <a:xfrm>
-            <a:off x="9288403" y="1783080"/>
+            <a:off x="5524910" y="1783080"/>
             <a:ext cx="0" cy="4197096"/>
           </a:xfrm>
           <a:prstGeom prst="line">
             <a:avLst/>
           </a:prstGeom>
           <a:noFill/>
-          <a:ln w="9525">
+          <a:ln w="6350">
             <a:solidFill>
-              <a:srgbClr val="D9E0EA"/>
+              <a:srgbClr val="EEF1F5"/>
             </a:solidFill>
             <a:prstDash val="solid"/>
           </a:ln>
@@ -6212,24 +6066,22 @@
       </p:sp>
       <p:sp>
         <p:nvSpPr>
-          <p:cNvPr id="24" name="Shape 22"/>
+          <p:cNvPr id="20" name="Shape 18"/>
           <p:cNvSpPr/>
           <p:nvPr/>
         </p:nvSpPr>
         <p:spPr>
           <a:xfrm>
-            <a:off x="10350555" y="1399032"/>
-            <a:ext cx="1175955" cy="329184"/>
-          </a:xfrm>
-          <a:prstGeom prst="rect">
-            <a:avLst/>
-          </a:prstGeom>
-          <a:solidFill>
-            <a:srgbClr val="F3F5F8"/>
-          </a:solidFill>
-          <a:ln w="12700">
+            <a:off x="6040667" y="1783080"/>
+            <a:ext cx="0" cy="4197096"/>
+          </a:xfrm>
+          <a:prstGeom prst="line">
+            <a:avLst/>
+          </a:prstGeom>
+          <a:noFill/>
+          <a:ln w="6350">
             <a:solidFill>
-              <a:srgbClr val="FFFFFF"/>
+              <a:srgbClr val="EEF1F5"/>
             </a:solidFill>
             <a:prstDash val="solid"/>
           </a:ln>
@@ -6237,61 +6089,22 @@
       </p:sp>
       <p:sp>
         <p:nvSpPr>
-          <p:cNvPr id="25" name="Text 23"/>
-          <p:cNvSpPr txBox="1"/>
-          <p:nvPr/>
-        </p:nvSpPr>
-        <p:spPr>
-          <a:xfrm>
-            <a:off x="10350555" y="1399032"/>
-            <a:ext cx="1175955" cy="329184"/>
-          </a:xfrm>
-          <a:prstGeom prst="rect">
-            <a:avLst/>
-          </a:prstGeom>
-          <a:noFill/>
-          <a:ln/>
-        </p:spPr>
-        <p:txBody>
-          <a:bodyPr wrap="square" lIns="0" tIns="0" rIns="0" bIns="0" rtlCol="0" anchor="ctr"/>
-          <a:lstStyle/>
-          <a:p>
-            <a:pPr algn="ctr" indent="0" marL="0">
-              <a:buNone/>
-            </a:pPr>
-            <a:r>
-              <a:rPr lang="en-US" sz="1000" b="1" dirty="0">
-                <a:solidFill>
-                  <a:srgbClr val="022A5B"/>
-                </a:solidFill>
-                <a:latin typeface="Arial" pitchFamily="34" charset="0"/>
-                <a:ea typeface="Arial" pitchFamily="34" charset="-122"/>
-                <a:cs typeface="Arial" pitchFamily="34" charset="-120"/>
-              </a:rPr>
-              <a:t>Mar</a:t>
-            </a:r>
-            <a:endParaRPr lang="en-US" sz="1000" dirty="0"/>
-          </a:p>
-        </p:txBody>
-      </p:sp>
-      <p:sp>
-        <p:nvSpPr>
-          <p:cNvPr id="26" name="Shape 24"/>
+          <p:cNvPr id="21" name="Shape 19"/>
           <p:cNvSpPr/>
           <p:nvPr/>
         </p:nvSpPr>
         <p:spPr>
           <a:xfrm>
-            <a:off x="10350555" y="1783080"/>
+            <a:off x="6556424" y="1783080"/>
             <a:ext cx="0" cy="4197096"/>
           </a:xfrm>
           <a:prstGeom prst="line">
             <a:avLst/>
           </a:prstGeom>
           <a:noFill/>
-          <a:ln w="9525">
+          <a:ln w="6350">
             <a:solidFill>
-              <a:srgbClr val="D9E0EA"/>
+              <a:srgbClr val="EEF1F5"/>
             </a:solidFill>
             <a:prstDash val="solid"/>
           </a:ln>
@@ -6299,24 +6112,22 @@
       </p:sp>
       <p:sp>
         <p:nvSpPr>
-          <p:cNvPr id="27" name="Shape 25"/>
+          <p:cNvPr id="22" name="Shape 20"/>
           <p:cNvSpPr/>
           <p:nvPr/>
         </p:nvSpPr>
         <p:spPr>
           <a:xfrm>
-            <a:off x="11526510" y="1399032"/>
-            <a:ext cx="113802" cy="329184"/>
-          </a:xfrm>
-          <a:prstGeom prst="rect">
-            <a:avLst/>
-          </a:prstGeom>
-          <a:solidFill>
-            <a:srgbClr val="F3F5F8"/>
-          </a:solidFill>
-          <a:ln w="12700">
+            <a:off x="7072181" y="1783080"/>
+            <a:ext cx="0" cy="4197096"/>
+          </a:xfrm>
+          <a:prstGeom prst="line">
+            <a:avLst/>
+          </a:prstGeom>
+          <a:noFill/>
+          <a:ln w="6350">
             <a:solidFill>
-              <a:srgbClr val="FFFFFF"/>
+              <a:srgbClr val="EEF1F5"/>
             </a:solidFill>
             <a:prstDash val="solid"/>
           </a:ln>
@@ -6324,22 +6135,22 @@
       </p:sp>
       <p:sp>
         <p:nvSpPr>
-          <p:cNvPr id="28" name="Shape 26"/>
+          <p:cNvPr id="23" name="Shape 21"/>
           <p:cNvSpPr/>
           <p:nvPr/>
         </p:nvSpPr>
         <p:spPr>
           <a:xfrm>
-            <a:off x="11526510" y="1783080"/>
+            <a:off x="7587937" y="1783080"/>
             <a:ext cx="0" cy="4197096"/>
           </a:xfrm>
           <a:prstGeom prst="line">
             <a:avLst/>
           </a:prstGeom>
           <a:noFill/>
-          <a:ln w="9525">
+          <a:ln w="6350">
             <a:solidFill>
-              <a:srgbClr val="D9E0EA"/>
+              <a:srgbClr val="EEF1F5"/>
             </a:solidFill>
             <a:prstDash val="solid"/>
           </a:ln>
@@ -6347,81 +6158,164 @@
       </p:sp>
       <p:sp>
         <p:nvSpPr>
-          <p:cNvPr id="29" name="Text 27"/>
-          <p:cNvSpPr txBox="1"/>
-          <p:nvPr/>
-        </p:nvSpPr>
-        <p:spPr>
-          <a:xfrm>
-            <a:off x="3977640" y="1143000"/>
-            <a:ext cx="1828800" cy="228600"/>
-          </a:xfrm>
-          <a:prstGeom prst="rect">
-            <a:avLst/>
-          </a:prstGeom>
-          <a:noFill/>
-          <a:ln/>
-        </p:spPr>
-        <p:txBody>
-          <a:bodyPr wrap="square" lIns="0" tIns="0" rIns="0" bIns="0" rtlCol="0" anchor="ctr"/>
-          <a:lstStyle/>
-          <a:p>
-            <a:pPr indent="0" marL="0">
-              <a:buNone/>
-            </a:pPr>
-            <a:r>
-              <a:rPr lang="en-US" sz="900" b="1" dirty="0">
-                <a:solidFill>
-                  <a:srgbClr val="6B7280"/>
-                </a:solidFill>
-                <a:latin typeface="Arial" pitchFamily="34" charset="0"/>
-                <a:ea typeface="Arial" pitchFamily="34" charset="-122"/>
-                <a:cs typeface="Arial" pitchFamily="34" charset="-120"/>
-              </a:rPr>
-              <a:t>2026</a:t>
-            </a:r>
-            <a:endParaRPr lang="en-US" sz="900" dirty="0"/>
-          </a:p>
-        </p:txBody>
-      </p:sp>
-      <p:sp>
-        <p:nvSpPr>
-          <p:cNvPr id="30" name="Text 28"/>
-          <p:cNvSpPr txBox="1"/>
-          <p:nvPr/>
-        </p:nvSpPr>
-        <p:spPr>
-          <a:xfrm>
-            <a:off x="8112448" y="1143000"/>
-            <a:ext cx="1828800" cy="228600"/>
-          </a:xfrm>
-          <a:prstGeom prst="rect">
-            <a:avLst/>
-          </a:prstGeom>
-          <a:noFill/>
-          <a:ln/>
-        </p:spPr>
-        <p:txBody>
-          <a:bodyPr wrap="square" lIns="0" tIns="0" rIns="0" bIns="0" rtlCol="0" anchor="ctr"/>
-          <a:lstStyle/>
-          <a:p>
-            <a:pPr indent="0" marL="0">
-              <a:buNone/>
-            </a:pPr>
-            <a:r>
-              <a:rPr lang="en-US" sz="900" b="1" dirty="0">
-                <a:solidFill>
-                  <a:srgbClr val="6B7280"/>
-                </a:solidFill>
-                <a:latin typeface="Arial" pitchFamily="34" charset="0"/>
-                <a:ea typeface="Arial" pitchFamily="34" charset="-122"/>
-                <a:cs typeface="Arial" pitchFamily="34" charset="-120"/>
-              </a:rPr>
-              <a:t>2027</a:t>
-            </a:r>
-            <a:endParaRPr lang="en-US" sz="900" dirty="0"/>
-          </a:p>
-        </p:txBody>
+          <p:cNvPr id="24" name="Shape 22"/>
+          <p:cNvSpPr/>
+          <p:nvPr/>
+        </p:nvSpPr>
+        <p:spPr>
+          <a:xfrm>
+            <a:off x="8103694" y="1783080"/>
+            <a:ext cx="0" cy="4197096"/>
+          </a:xfrm>
+          <a:prstGeom prst="line">
+            <a:avLst/>
+          </a:prstGeom>
+          <a:noFill/>
+          <a:ln w="6350">
+            <a:solidFill>
+              <a:srgbClr val="EEF1F5"/>
+            </a:solidFill>
+            <a:prstDash val="solid"/>
+          </a:ln>
+        </p:spPr>
+      </p:sp>
+      <p:sp>
+        <p:nvSpPr>
+          <p:cNvPr id="25" name="Shape 23"/>
+          <p:cNvSpPr/>
+          <p:nvPr/>
+        </p:nvSpPr>
+        <p:spPr>
+          <a:xfrm>
+            <a:off x="8619451" y="1783080"/>
+            <a:ext cx="0" cy="4197096"/>
+          </a:xfrm>
+          <a:prstGeom prst="line">
+            <a:avLst/>
+          </a:prstGeom>
+          <a:noFill/>
+          <a:ln w="6350">
+            <a:solidFill>
+              <a:srgbClr val="EEF1F5"/>
+            </a:solidFill>
+            <a:prstDash val="solid"/>
+          </a:ln>
+        </p:spPr>
+      </p:sp>
+      <p:sp>
+        <p:nvSpPr>
+          <p:cNvPr id="26" name="Shape 24"/>
+          <p:cNvSpPr/>
+          <p:nvPr/>
+        </p:nvSpPr>
+        <p:spPr>
+          <a:xfrm>
+            <a:off x="9135208" y="1783080"/>
+            <a:ext cx="0" cy="4197096"/>
+          </a:xfrm>
+          <a:prstGeom prst="line">
+            <a:avLst/>
+          </a:prstGeom>
+          <a:noFill/>
+          <a:ln w="6350">
+            <a:solidFill>
+              <a:srgbClr val="EEF1F5"/>
+            </a:solidFill>
+            <a:prstDash val="solid"/>
+          </a:ln>
+        </p:spPr>
+      </p:sp>
+      <p:sp>
+        <p:nvSpPr>
+          <p:cNvPr id="27" name="Shape 25"/>
+          <p:cNvSpPr/>
+          <p:nvPr/>
+        </p:nvSpPr>
+        <p:spPr>
+          <a:xfrm>
+            <a:off x="9650964" y="1783080"/>
+            <a:ext cx="0" cy="4197096"/>
+          </a:xfrm>
+          <a:prstGeom prst="line">
+            <a:avLst/>
+          </a:prstGeom>
+          <a:noFill/>
+          <a:ln w="6350">
+            <a:solidFill>
+              <a:srgbClr val="EEF1F5"/>
+            </a:solidFill>
+            <a:prstDash val="solid"/>
+          </a:ln>
+        </p:spPr>
+      </p:sp>
+      <p:sp>
+        <p:nvSpPr>
+          <p:cNvPr id="28" name="Shape 26"/>
+          <p:cNvSpPr/>
+          <p:nvPr/>
+        </p:nvSpPr>
+        <p:spPr>
+          <a:xfrm>
+            <a:off x="10166721" y="1783080"/>
+            <a:ext cx="0" cy="4197096"/>
+          </a:xfrm>
+          <a:prstGeom prst="line">
+            <a:avLst/>
+          </a:prstGeom>
+          <a:noFill/>
+          <a:ln w="6350">
+            <a:solidFill>
+              <a:srgbClr val="EEF1F5"/>
+            </a:solidFill>
+            <a:prstDash val="solid"/>
+          </a:ln>
+        </p:spPr>
+      </p:sp>
+      <p:sp>
+        <p:nvSpPr>
+          <p:cNvPr id="29" name="Shape 27"/>
+          <p:cNvSpPr/>
+          <p:nvPr/>
+        </p:nvSpPr>
+        <p:spPr>
+          <a:xfrm>
+            <a:off x="10682478" y="1783080"/>
+            <a:ext cx="0" cy="4197096"/>
+          </a:xfrm>
+          <a:prstGeom prst="line">
+            <a:avLst/>
+          </a:prstGeom>
+          <a:noFill/>
+          <a:ln w="6350">
+            <a:solidFill>
+              <a:srgbClr val="EEF1F5"/>
+            </a:solidFill>
+            <a:prstDash val="solid"/>
+          </a:ln>
+        </p:spPr>
+      </p:sp>
+      <p:sp>
+        <p:nvSpPr>
+          <p:cNvPr id="30" name="Shape 28"/>
+          <p:cNvSpPr/>
+          <p:nvPr/>
+        </p:nvSpPr>
+        <p:spPr>
+          <a:xfrm>
+            <a:off x="11198235" y="1783080"/>
+            <a:ext cx="0" cy="4197096"/>
+          </a:xfrm>
+          <a:prstGeom prst="line">
+            <a:avLst/>
+          </a:prstGeom>
+          <a:noFill/>
+          <a:ln w="6350">
+            <a:solidFill>
+              <a:srgbClr val="EEF1F5"/>
+            </a:solidFill>
+            <a:prstDash val="solid"/>
+          </a:ln>
+        </p:spPr>
       </p:sp>
       <p:sp>
         <p:nvSpPr>
@@ -6496,7 +6390,7 @@
         <p:spPr>
           <a:xfrm>
             <a:off x="3977640" y="1847088"/>
-            <a:ext cx="948350" cy="118872"/>
+            <a:ext cx="1326232" cy="118872"/>
           </a:xfrm>
           <a:prstGeom prst="rect">
             <a:avLst/>
@@ -6545,7 +6439,7 @@
                 <a:ea typeface="Arial" pitchFamily="34" charset="-122"/>
                 <a:cs typeface="Arial" pitchFamily="34" charset="-120"/>
               </a:rPr>
-              <a:t>14/09 – 09/10</a:t>
+              <a:t>14/09 – 02/10</a:t>
             </a:r>
             <a:endParaRPr lang="en-US" sz="750" dirty="0"/>
           </a:p>
@@ -6599,7 +6493,7 @@
         <p:spPr>
           <a:xfrm>
             <a:off x="3977640" y="2075688"/>
-            <a:ext cx="417274" cy="155448"/>
+            <a:ext cx="663116" cy="155448"/>
           </a:xfrm>
           <a:prstGeom prst="roundRect">
             <a:avLst>
@@ -6652,7 +6546,7 @@
                 <a:ea typeface="Arial" pitchFamily="34" charset="-122"/>
                 <a:cs typeface="Arial" pitchFamily="34" charset="-120"/>
               </a:rPr>
-              <a:t>14/09 – 25/09</a:t>
+              <a:t>14/09 – 23/09</a:t>
             </a:r>
             <a:endParaRPr lang="en-US" sz="750" dirty="0"/>
           </a:p>
@@ -6705,8 +6599,8 @@
         </p:nvSpPr>
         <p:spPr>
           <a:xfrm>
-            <a:off x="4243178" y="2322576"/>
-            <a:ext cx="417274" cy="155448"/>
+            <a:off x="3977640" y="2322576"/>
+            <a:ext cx="810475" cy="155448"/>
           </a:xfrm>
           <a:prstGeom prst="roundRect">
             <a:avLst>
@@ -6759,7 +6653,7 @@
                 <a:ea typeface="Arial" pitchFamily="34" charset="-122"/>
                 <a:cs typeface="Arial" pitchFamily="34" charset="-120"/>
               </a:rPr>
-              <a:t>21/09 – 02/10</a:t>
+              <a:t>14/09 – 25/09</a:t>
             </a:r>
             <a:endParaRPr lang="en-US" sz="750" dirty="0"/>
           </a:p>
@@ -6812,8 +6706,8 @@
         </p:nvSpPr>
         <p:spPr>
           <a:xfrm>
-            <a:off x="4508716" y="2569464"/>
-            <a:ext cx="682812" cy="155448"/>
+            <a:off x="4493397" y="2569464"/>
+            <a:ext cx="1326232" cy="155448"/>
           </a:xfrm>
           <a:prstGeom prst="roundRect">
             <a:avLst>
@@ -6866,7 +6760,7 @@
                 <a:ea typeface="Arial" pitchFamily="34" charset="-122"/>
                 <a:cs typeface="Arial" pitchFamily="34" charset="-120"/>
               </a:rPr>
-              <a:t>28/09 – 16/10</a:t>
+              <a:t>21/09 – 09/10</a:t>
             </a:r>
             <a:endParaRPr lang="en-US" sz="750" dirty="0"/>
           </a:p>
@@ -6944,8 +6838,8 @@
         </p:nvSpPr>
         <p:spPr>
           <a:xfrm>
-            <a:off x="5039793" y="2834640"/>
-            <a:ext cx="1479427" cy="118872"/>
+            <a:off x="5009154" y="2834640"/>
+            <a:ext cx="2873502" cy="118872"/>
           </a:xfrm>
           <a:prstGeom prst="rect">
             <a:avLst/>
@@ -6994,7 +6888,7 @@
                 <a:ea typeface="Arial" pitchFamily="34" charset="-122"/>
                 <a:cs typeface="Arial" pitchFamily="34" charset="-120"/>
               </a:rPr>
-              <a:t>12/10 – 20/11</a:t>
+              <a:t>28/09 – 06/11</a:t>
             </a:r>
             <a:endParaRPr lang="en-US" sz="750" dirty="0"/>
           </a:p>
@@ -7047,8 +6941,8 @@
         </p:nvSpPr>
         <p:spPr>
           <a:xfrm>
-            <a:off x="5039793" y="3063240"/>
-            <a:ext cx="1213889" cy="155448"/>
+            <a:off x="5009154" y="3063240"/>
+            <a:ext cx="2357745" cy="155448"/>
           </a:xfrm>
           <a:prstGeom prst="roundRect">
             <a:avLst>
@@ -7101,7 +6995,7 @@
                 <a:ea typeface="Arial" pitchFamily="34" charset="-122"/>
                 <a:cs typeface="Arial" pitchFamily="34" charset="-120"/>
               </a:rPr>
-              <a:t>12/10 – 13/11</a:t>
+              <a:t>28/09 – 30/10</a:t>
             </a:r>
             <a:endParaRPr lang="en-US" sz="750" dirty="0"/>
           </a:p>
@@ -7154,8 +7048,8 @@
         </p:nvSpPr>
         <p:spPr>
           <a:xfrm>
-            <a:off x="5039793" y="3310128"/>
-            <a:ext cx="682812" cy="155448"/>
+            <a:off x="5524910" y="3310128"/>
+            <a:ext cx="1326232" cy="155448"/>
           </a:xfrm>
           <a:prstGeom prst="roundRect">
             <a:avLst>
@@ -7208,7 +7102,7 @@
                 <a:ea typeface="Arial" pitchFamily="34" charset="-122"/>
                 <a:cs typeface="Arial" pitchFamily="34" charset="-120"/>
               </a:rPr>
-              <a:t>12/10 – 30/10</a:t>
+              <a:t>05/10 – 23/10</a:t>
             </a:r>
             <a:endParaRPr lang="en-US" sz="750" dirty="0"/>
           </a:p>
@@ -7261,8 +7155,8 @@
         </p:nvSpPr>
         <p:spPr>
           <a:xfrm>
-            <a:off x="5305331" y="3557016"/>
-            <a:ext cx="948350" cy="155448"/>
+            <a:off x="5524910" y="3557016"/>
+            <a:ext cx="1841988" cy="155448"/>
           </a:xfrm>
           <a:prstGeom prst="roundRect">
             <a:avLst>
@@ -7315,7 +7209,7 @@
                 <a:ea typeface="Arial" pitchFamily="34" charset="-122"/>
                 <a:cs typeface="Arial" pitchFamily="34" charset="-120"/>
               </a:rPr>
-              <a:t>19/10 – 13/11</a:t>
+              <a:t>05/10 – 30/10</a:t>
             </a:r>
             <a:endParaRPr lang="en-US" sz="750" dirty="0"/>
           </a:p>
@@ -7368,8 +7262,8 @@
         </p:nvSpPr>
         <p:spPr>
           <a:xfrm>
-            <a:off x="5570869" y="3803904"/>
-            <a:ext cx="948350" cy="155448"/>
+            <a:off x="6040667" y="3803904"/>
+            <a:ext cx="1841988" cy="155448"/>
           </a:xfrm>
           <a:prstGeom prst="roundRect">
             <a:avLst>
@@ -7422,7 +7316,7 @@
                 <a:ea typeface="Arial" pitchFamily="34" charset="-122"/>
                 <a:cs typeface="Arial" pitchFamily="34" charset="-120"/>
               </a:rPr>
-              <a:t>26/10 – 20/11</a:t>
+              <a:t>12/10 – 06/11</a:t>
             </a:r>
             <a:endParaRPr lang="en-US" sz="750" dirty="0"/>
           </a:p>
@@ -7500,8 +7394,8 @@
         </p:nvSpPr>
         <p:spPr>
           <a:xfrm>
-            <a:off x="6633021" y="4069080"/>
-            <a:ext cx="948350" cy="118872"/>
+            <a:off x="8103694" y="4069080"/>
+            <a:ext cx="810475" cy="118872"/>
           </a:xfrm>
           <a:prstGeom prst="rect">
             <a:avLst/>
@@ -7550,7 +7444,7 @@
                 <a:ea typeface="Arial" pitchFamily="34" charset="-122"/>
                 <a:cs typeface="Arial" pitchFamily="34" charset="-120"/>
               </a:rPr>
-              <a:t>23/11 – 18/12</a:t>
+              <a:t>09/11 – 20/11</a:t>
             </a:r>
             <a:endParaRPr lang="en-US" sz="750" dirty="0"/>
           </a:p>
@@ -7603,8 +7497,8 @@
         </p:nvSpPr>
         <p:spPr>
           <a:xfrm>
-            <a:off x="6633021" y="4297680"/>
-            <a:ext cx="417274" cy="155448"/>
+            <a:off x="8103694" y="4297680"/>
+            <a:ext cx="294718" cy="155448"/>
           </a:xfrm>
           <a:prstGeom prst="roundRect">
             <a:avLst>
@@ -7657,7 +7551,7 @@
                 <a:ea typeface="Arial" pitchFamily="34" charset="-122"/>
                 <a:cs typeface="Arial" pitchFamily="34" charset="-120"/>
               </a:rPr>
-              <a:t>23/11 – 04/12</a:t>
+              <a:t>09/11 – 13/11</a:t>
             </a:r>
             <a:endParaRPr lang="en-US" sz="750" dirty="0"/>
           </a:p>
@@ -7710,8 +7604,8 @@
         </p:nvSpPr>
         <p:spPr>
           <a:xfrm>
-            <a:off x="6898560" y="4544568"/>
-            <a:ext cx="417274" cy="155448"/>
+            <a:off x="8324733" y="4544568"/>
+            <a:ext cx="442077" cy="155448"/>
           </a:xfrm>
           <a:prstGeom prst="roundRect">
             <a:avLst>
@@ -7764,7 +7658,7 @@
                 <a:ea typeface="Arial" pitchFamily="34" charset="-122"/>
                 <a:cs typeface="Arial" pitchFamily="34" charset="-120"/>
               </a:rPr>
-              <a:t>30/11 – 11/12</a:t>
+              <a:t>12/11 – 18/11</a:t>
             </a:r>
             <a:endParaRPr lang="en-US" sz="750" dirty="0"/>
           </a:p>
@@ -7817,8 +7711,8 @@
         </p:nvSpPr>
         <p:spPr>
           <a:xfrm>
-            <a:off x="7164098" y="4791456"/>
-            <a:ext cx="417274" cy="155448"/>
+            <a:off x="8619451" y="4791456"/>
+            <a:ext cx="294718" cy="155448"/>
           </a:xfrm>
           <a:prstGeom prst="roundRect">
             <a:avLst>
@@ -7871,7 +7765,7 @@
                 <a:ea typeface="Arial" pitchFamily="34" charset="-122"/>
                 <a:cs typeface="Arial" pitchFamily="34" charset="-120"/>
               </a:rPr>
-              <a:t>07/12 – 18/12</a:t>
+              <a:t>16/11 – 20/11</a:t>
             </a:r>
             <a:endParaRPr lang="en-US" sz="750" dirty="0"/>
           </a:p>
@@ -7949,8 +7843,8 @@
         </p:nvSpPr>
         <p:spPr>
           <a:xfrm>
-            <a:off x="8491788" y="5056632"/>
-            <a:ext cx="3072656" cy="118872"/>
+            <a:off x="9135208" y="5056632"/>
+            <a:ext cx="2210386" cy="118872"/>
           </a:xfrm>
           <a:prstGeom prst="rect">
             <a:avLst/>
@@ -7999,7 +7893,7 @@
                 <a:ea typeface="Arial" pitchFamily="34" charset="-122"/>
                 <a:cs typeface="Arial" pitchFamily="34" charset="-120"/>
               </a:rPr>
-              <a:t>11/01 – 02/04</a:t>
+              <a:t>23/11 – 23/12</a:t>
             </a:r>
             <a:endParaRPr lang="en-US" sz="750" dirty="0"/>
           </a:p>
@@ -8052,8 +7946,8 @@
         </p:nvSpPr>
         <p:spPr>
           <a:xfrm>
-            <a:off x="8491788" y="5285232"/>
-            <a:ext cx="2807117" cy="155448"/>
+            <a:off x="9135208" y="5285232"/>
+            <a:ext cx="1841988" cy="155448"/>
           </a:xfrm>
           <a:prstGeom prst="roundRect">
             <a:avLst>
@@ -8106,7 +8000,7 @@
                 <a:ea typeface="Arial" pitchFamily="34" charset="-122"/>
                 <a:cs typeface="Arial" pitchFamily="34" charset="-120"/>
               </a:rPr>
-              <a:t>11/01 – 26/03</a:t>
+              <a:t>23/11 – 18/12</a:t>
             </a:r>
             <a:endParaRPr lang="en-US" sz="750" dirty="0"/>
           </a:p>
@@ -8159,8 +8053,8 @@
         </p:nvSpPr>
         <p:spPr>
           <a:xfrm>
-            <a:off x="9022865" y="5532120"/>
-            <a:ext cx="2541579" cy="155448"/>
+            <a:off x="10166721" y="5532120"/>
+            <a:ext cx="1178873" cy="155448"/>
           </a:xfrm>
           <a:prstGeom prst="roundRect">
             <a:avLst>
@@ -8213,7 +8107,7 @@
                 <a:ea typeface="Arial" pitchFamily="34" charset="-122"/>
                 <a:cs typeface="Arial" pitchFamily="34" charset="-120"/>
               </a:rPr>
-              <a:t>25/01 – 02/04</a:t>
+              <a:t>07/12 – 23/12</a:t>
             </a:r>
             <a:endParaRPr lang="en-US" sz="750" dirty="0"/>
           </a:p>
@@ -8252,7 +8146,7 @@
                 <a:ea typeface="Arial" pitchFamily="34" charset="-122"/>
                 <a:cs typeface="Arial" pitchFamily="34" charset="-120"/>
               </a:rPr>
-              <a:t>Seguimiento mensual de indicadores</a:t>
+              <a:t>Cierre y primera medición de indicadores</a:t>
             </a:r>
             <a:endParaRPr lang="en-US" sz="900" dirty="0"/>
           </a:p>
@@ -8266,8 +8160,8 @@
         </p:nvSpPr>
         <p:spPr>
           <a:xfrm>
-            <a:off x="9288403" y="5779008"/>
-            <a:ext cx="2276041" cy="155448"/>
+            <a:off x="10682478" y="5779008"/>
+            <a:ext cx="663116" cy="155448"/>
           </a:xfrm>
           <a:prstGeom prst="roundRect">
             <a:avLst>
@@ -8320,7 +8214,7 @@
                 <a:ea typeface="Arial" pitchFamily="34" charset="-122"/>
                 <a:cs typeface="Arial" pitchFamily="34" charset="-120"/>
               </a:rPr>
-              <a:t>01/02 – 02/04</a:t>
+              <a:t>14/12 – 23/12</a:t>
             </a:r>
             <a:endParaRPr lang="en-US" sz="750" dirty="0"/>
           </a:p>
@@ -8334,7 +8228,7 @@
         </p:nvSpPr>
         <p:spPr>
           <a:xfrm>
-            <a:off x="4825406" y="1805940"/>
+            <a:off x="5203288" y="1805940"/>
             <a:ext cx="201168" cy="201168"/>
           </a:xfrm>
           <a:prstGeom prst="diamond">
@@ -8359,7 +8253,7 @@
         </p:nvSpPr>
         <p:spPr>
           <a:xfrm>
-            <a:off x="6418635" y="2793492"/>
+            <a:off x="7782072" y="2793492"/>
             <a:ext cx="201168" cy="201168"/>
           </a:xfrm>
           <a:prstGeom prst="diamond">
@@ -8384,7 +8278,7 @@
         </p:nvSpPr>
         <p:spPr>
           <a:xfrm>
-            <a:off x="7480788" y="4027932"/>
+            <a:off x="8813585" y="4027932"/>
             <a:ext cx="201168" cy="201168"/>
           </a:xfrm>
           <a:prstGeom prst="diamond">
@@ -8409,7 +8303,7 @@
         </p:nvSpPr>
         <p:spPr>
           <a:xfrm>
-            <a:off x="11463860" y="5015484"/>
+            <a:off x="11245010" y="5015484"/>
             <a:ext cx="201168" cy="201168"/>
           </a:xfrm>
           <a:prstGeom prst="diamond">
@@ -8484,7 +8378,7 @@
                 <a:ea typeface="Arial" pitchFamily="34" charset="-122"/>
                 <a:cs typeface="Arial" pitchFamily="34" charset="-120"/>
               </a:rPr>
-              <a:t>Hitos: 09/10 layout y presupuesto aprobados · 20/11 maquetas y tótems listos · 18/12 go/no-go del despliegue · 02/04 100% de los turnos certificados</a:t>
+              <a:t>Hitos: 02/10 layout y presupuesto aprobados · 06/11 maquetas y tótems listos · 20/11 go/no-go del despliegue · 23/12 100% de los turnos certificados</a:t>
             </a:r>
             <a:endParaRPr lang="en-US" sz="900" dirty="0"/>
           </a:p>
@@ -8523,7 +8417,7 @@
                 <a:ea typeface="Arial" pitchFamily="34" charset="-122"/>
                 <a:cs typeface="Arial" pitchFamily="34" charset="-120"/>
               </a:rPr>
-              <a:t>Duración total: 29 semanas (14/09/2026 a 02/04/2027), con receso de fin de año del 21/12 al 08/01. Fechas propuestas: se ajustan con la fecha real de aprobación.</a:t>
+              <a:t>Duración total: 15 semanas (14/09 a 23/12/2026). Para llegar a diciembre las fases se solapan: la construcción arranca antes de cerrar el diseño y el despliegue sigue al piloto sin pausa.</a:t>
             </a:r>
             <a:endParaRPr lang="en-US" sz="900" dirty="0"/>
           </a:p>

</xml_diff>